<commit_message>
Fixed a spacing error
</commit_message>
<xml_diff>
--- a/docs/CampusGuard_Demo_final.pptx
+++ b/docs/CampusGuard_Demo_final.pptx
@@ -1620,10 +1620,22 @@
                 <a:ea typeface="Calibri" pitchFamily="34" charset="-122"/>
                 <a:cs typeface="Calibri" pitchFamily="34" charset="-120"/>
               </a:rPr>
-              <a:t>We run the whole system inside a Docker </a:t>
-            </a:r>
-            <a:r>
-              <a:rPr lang="en-US" sz="1400" dirty="0" err="1">
+              <a:t>We run the whole system inside a Docker container</a:t>
+            </a:r>
+          </a:p>
+          <a:p>
+            <a:pPr marL="342900" indent="-342900">
+              <a:lnSpc>
+                <a:spcPct val="105000"/>
+              </a:lnSpc>
+              <a:spcAft>
+                <a:spcPts val="800"/>
+              </a:spcAft>
+              <a:buSzPct val="100000"/>
+              <a:buChar char="•"/>
+            </a:pPr>
+            <a:r>
+              <a:rPr lang="en-US" sz="1400" dirty="0">
                 <a:solidFill>
                   <a:srgbClr val="1F2A44"/>
                 </a:solidFill>
@@ -1631,18 +1643,7 @@
                 <a:ea typeface="Calibri" pitchFamily="34" charset="-122"/>
                 <a:cs typeface="Calibri" pitchFamily="34" charset="-120"/>
               </a:rPr>
-              <a:t>containerThe</a:t>
-            </a:r>
-            <a:r>
-              <a:rPr lang="en-US" sz="1400" dirty="0">
-                <a:solidFill>
-                  <a:srgbClr val="1F2A44"/>
-                </a:solidFill>
-                <a:latin typeface="Calibri" pitchFamily="34" charset="0"/>
-                <a:ea typeface="Calibri" pitchFamily="34" charset="-122"/>
-                <a:cs typeface="Calibri" pitchFamily="34" charset="-120"/>
-              </a:rPr>
-              <a:t> command docker compose up --build tells Docker to build an Ubuntu 22.04 image, install the compiler and debugging tools, and then run our Makefile.</a:t>
+              <a:t>The command docker compose up --build tells Docker to build an Ubuntu 22.04 image, install the compiler and debugging tools, and then run our Makefile.</a:t>
             </a:r>
             <a:endParaRPr lang="en-US" sz="1400" dirty="0"/>
           </a:p>

</xml_diff>

<commit_message>
Added extra page for state
</commit_message>
<xml_diff>
--- a/docs/CampusGuard_Demo_final.pptx
+++ b/docs/CampusGuard_Demo_final.pptx
@@ -5,7 +5,7 @@
     <p:sldMasterId id="2147483648" r:id="rId1"/>
   </p:sldMasterIdLst>
   <p:notesMasterIdLst>
-    <p:notesMasterId r:id="rId13"/>
+    <p:notesMasterId r:id="rId14"/>
   </p:notesMasterIdLst>
   <p:sldIdLst>
     <p:sldId id="256" r:id="rId2"/>
@@ -15,10 +15,11 @@
     <p:sldId id="260" r:id="rId6"/>
     <p:sldId id="261" r:id="rId7"/>
     <p:sldId id="262" r:id="rId8"/>
-    <p:sldId id="263" r:id="rId9"/>
-    <p:sldId id="264" r:id="rId10"/>
-    <p:sldId id="265" r:id="rId11"/>
-    <p:sldId id="266" r:id="rId12"/>
+    <p:sldId id="268" r:id="rId9"/>
+    <p:sldId id="263" r:id="rId10"/>
+    <p:sldId id="264" r:id="rId11"/>
+    <p:sldId id="265" r:id="rId12"/>
+    <p:sldId id="266" r:id="rId13"/>
   </p:sldIdLst>
   <p:sldSz cx="9144000" cy="5143500" type="screen16x9"/>
   <p:notesSz cx="5143500" cy="9144000"/>
@@ -380,7 +381,7 @@
           <a:p>
             <a:r>
               <a:rPr lang="en-US" dirty="0"/>
-              <a:t>[Terrence] Explain what each tool is actually checking, in plain terms, before showing the numbers. "Valgrind checks that everything we created with new was properly deleted. Here it says forty-one allocations, forty-one frees, zero left in use, zero errors, which means nothing leaked." Then GDB: "This is not about finding a bug for its own sake, it is proof we can pause the program mid-run and inspect it. Here we stopped at the very start, stepped forward line by line, and watched the legacy hardware object actually get constructed."</a:t>
+              <a:t>[Terrence] Say this framing first: "A tutor might point at a specific arrow on our sequence diagram and ask, show me exactly where this happens in the code. Here is how we would answer that, for the chemical spill story." Then go down the table, and for at least the first two rows, actually open the file and show the matching line, so it is not just a slide claim.</a:t>
             </a:r>
           </a:p>
         </p:txBody>
@@ -467,7 +468,7 @@
           <a:p>
             <a:r>
               <a:rPr lang="en-US" dirty="0"/>
-              <a:t>[Terrence] Keep this short and honest. "We split the six patterns by area, not evenly by file count. Each person built their area on its own branch, and we merged through pull requests rather than copying files around, so our GitHub history actually shows the work happening over time, not just at the end." Finish with: "All three of us can explain any part of this system, not just our own piece, because we reviewed each other's pull requests before merging."</a:t>
+              <a:t>[Terrence] Explain what each tool is actually checking, in plain terms, before showing the numbers. "Valgrind checks that everything we created with new was properly deleted. Here it says forty-one allocations, forty-one frees, zero left in use, zero errors, which means nothing leaked." Then GDB: "This is not about finding a bug for its own sake, it is proof we can pause the program mid-run and inspect it. Here we stopped at the very start, stepped forward line by line, and watched the legacy hardware object actually get constructed."</a:t>
             </a:r>
           </a:p>
         </p:txBody>
@@ -490,6 +491,93 @@
             <a:fld id="{F7021451-1387-4CA6-816F-3879F97B5CBC}" type="slidenum">
               <a:rPr lang="en-US"/>
               <a:t>11</a:t>
+            </a:fld>
+            <a:endParaRPr lang="en-US"/>
+          </a:p>
+        </p:txBody>
+      </p:sp>
+    </p:spTree>
+    <p:extLst>
+      <p:ext uri="{BB962C8B-B14F-4D97-AF65-F5344CB8AC3E}">
+        <p14:creationId xmlns:p14="http://schemas.microsoft.com/office/powerpoint/2010/main" val="1024086991"/>
+      </p:ext>
+    </p:extLst>
+  </p:cSld>
+  <p:clrMapOvr>
+    <a:masterClrMapping/>
+  </p:clrMapOvr>
+</p:notes>
+</file>
+
+<file path=ppt/notesSlides/notesSlide12.xml><?xml version="1.0" encoding="utf-8"?>
+<p:notes xmlns:a="http://schemas.openxmlformats.org/drawingml/2006/main" xmlns:r="http://schemas.openxmlformats.org/officeDocument/2006/relationships" xmlns:p="http://schemas.openxmlformats.org/presentationml/2006/main">
+  <p:cSld>
+    <p:spTree>
+      <p:nvGrpSpPr>
+        <p:cNvPr id="1" name=""/>
+        <p:cNvGrpSpPr/>
+        <p:nvPr/>
+      </p:nvGrpSpPr>
+      <p:grpSpPr>
+        <a:xfrm>
+          <a:off x="0" y="0"/>
+          <a:ext cx="0" cy="0"/>
+          <a:chOff x="0" y="0"/>
+          <a:chExt cx="0" cy="0"/>
+        </a:xfrm>
+      </p:grpSpPr>
+      <p:sp>
+        <p:nvSpPr>
+          <p:cNvPr id="2" name="Slide Image Placeholder 1"/>
+          <p:cNvSpPr>
+            <a:spLocks noGrp="1" noRot="1" noChangeAspect="1"/>
+          </p:cNvSpPr>
+          <p:nvPr>
+            <p:ph type="sldImg"/>
+          </p:nvPr>
+        </p:nvSpPr>
+        <p:spPr/>
+      </p:sp>
+      <p:sp>
+        <p:nvSpPr>
+          <p:cNvPr id="3" name="Notes Placeholder 2"/>
+          <p:cNvSpPr>
+            <a:spLocks noGrp="1"/>
+          </p:cNvSpPr>
+          <p:nvPr>
+            <p:ph type="body" idx="1"/>
+          </p:nvPr>
+        </p:nvSpPr>
+        <p:spPr/>
+        <p:txBody>
+          <a:bodyPr/>
+          <a:lstStyle/>
+          <a:p>
+            <a:r>
+              <a:rPr lang="en-US" dirty="0"/>
+              <a:t>[Terrence] Keep this short and honest. "We split the six patterns by area, not evenly by file count. Each person built their area on its own branch, and we merged through pull requests rather than copying files around, so our GitHub history actually shows the work happening over time, not just at the end." Finish with: "All three of us can explain any part of this system, not just our own piece, because we reviewed each other's pull requests before merging."</a:t>
+            </a:r>
+          </a:p>
+        </p:txBody>
+      </p:sp>
+      <p:sp>
+        <p:nvSpPr>
+          <p:cNvPr id="4" name="Slide Number Placeholder 3"/>
+          <p:cNvSpPr>
+            <a:spLocks noGrp="1"/>
+          </p:cNvSpPr>
+          <p:nvPr>
+            <p:ph type="sldNum" sz="quarter" idx="10"/>
+          </p:nvPr>
+        </p:nvSpPr>
+        <p:spPr/>
+        <p:txBody>
+          <a:bodyPr/>
+          <a:lstStyle/>
+          <a:p>
+            <a:fld id="{F7021451-1387-4CA6-816F-3879F97B5CBC}" type="slidenum">
+              <a:rPr lang="en-US"/>
+              <a:t>12</a:t>
             </a:fld>
             <a:endParaRPr lang="en-US"/>
           </a:p>
@@ -1035,7 +1123,13 @@
   <p:cSld>
     <p:spTree>
       <p:nvGrpSpPr>
-        <p:cNvPr id="1" name=""/>
+        <p:cNvPr id="1" name="">
+          <a:extLst>
+            <a:ext uri="{FF2B5EF4-FFF2-40B4-BE49-F238E27FC236}">
+              <a16:creationId xmlns:a16="http://schemas.microsoft.com/office/drawing/2014/main" id="{61A402EF-EE3B-7C24-8A68-B23B140E3DA5}"/>
+            </a:ext>
+          </a:extLst>
+        </p:cNvPr>
         <p:cNvGrpSpPr/>
         <p:nvPr/>
       </p:nvGrpSpPr>
@@ -1049,7 +1143,13 @@
       </p:grpSpPr>
       <p:sp>
         <p:nvSpPr>
-          <p:cNvPr id="2" name="Slide Image Placeholder 1"/>
+          <p:cNvPr id="2" name="Slide Image Placeholder 1">
+            <a:extLst>
+              <a:ext uri="{FF2B5EF4-FFF2-40B4-BE49-F238E27FC236}">
+                <a16:creationId xmlns:a16="http://schemas.microsoft.com/office/drawing/2014/main" id="{A1CE5243-23D4-9978-AE1F-16725A831A5E}"/>
+              </a:ext>
+            </a:extLst>
+          </p:cNvPr>
           <p:cNvSpPr>
             <a:spLocks noGrp="1" noRot="1" noChangeAspect="1"/>
           </p:cNvSpPr>
@@ -1061,7 +1161,13 @@
       </p:sp>
       <p:sp>
         <p:nvSpPr>
-          <p:cNvPr id="3" name="Notes Placeholder 2"/>
+          <p:cNvPr id="3" name="Notes Placeholder 2">
+            <a:extLst>
+              <a:ext uri="{FF2B5EF4-FFF2-40B4-BE49-F238E27FC236}">
+                <a16:creationId xmlns:a16="http://schemas.microsoft.com/office/drawing/2014/main" id="{30F32654-67A7-C55A-13E3-7BAB2F26942E}"/>
+              </a:ext>
+            </a:extLst>
+          </p:cNvPr>
           <p:cNvSpPr>
             <a:spLocks noGrp="1"/>
           </p:cNvSpPr>
@@ -1076,14 +1182,20 @@
           <a:p>
             <a:r>
               <a:rPr lang="en-US" dirty="0"/>
-              <a:t>[Terrence] Keep this concrete and physical. "Whoever creates a command with new also hands it to the console, and from that point the console is responsible for deleting it, whether it fails immediately, gets undone later, or the program simply ends." Then the trickier one: "An incident owns its own current stage. The tricky part is, a stage sometimes has to replace itself while it is still running. We do not delete a stage while it is still in the middle of running its own code, we wait until it finishes, and only then swap it out safely." Finish simply: "Everything else, the mediator, the door system, the strategies, is just being borrowed. Whoever created it on the stack in main is the one who cleans it up."</a:t>
+              <a:t>[Enock] Give the tempting-but-wrong option first. "At first it looks like every emergency tactic does the same two things in the same order: touch the doors, then tell the mediator. That would suggest a simpler base class where the order is fixed for everyone." Then the counter-example, said slowly: "But imagine an active shooter situation. There, alerting people has to happen before anything to do with doors. If we had locked in a fixed order for every tactic, that situation literally could not be represented." Then land the benefit: "Because each tactic controls its own order completely, we can add a brand new emergency response later without changing a single line of existing code."</a:t>
             </a:r>
           </a:p>
         </p:txBody>
       </p:sp>
       <p:sp>
         <p:nvSpPr>
-          <p:cNvPr id="4" name="Slide Number Placeholder 3"/>
+          <p:cNvPr id="4" name="Slide Number Placeholder 3">
+            <a:extLst>
+              <a:ext uri="{FF2B5EF4-FFF2-40B4-BE49-F238E27FC236}">
+                <a16:creationId xmlns:a16="http://schemas.microsoft.com/office/drawing/2014/main" id="{915FD764-5E53-FDD5-69A7-3E902CD736BA}"/>
+              </a:ext>
+            </a:extLst>
+          </p:cNvPr>
           <p:cNvSpPr>
             <a:spLocks noGrp="1"/>
           </p:cNvSpPr>
@@ -1107,7 +1219,7 @@
     </p:spTree>
     <p:extLst>
       <p:ext uri="{BB962C8B-B14F-4D97-AF65-F5344CB8AC3E}">
-        <p14:creationId xmlns:p14="http://schemas.microsoft.com/office/powerpoint/2010/main" val="1024086991"/>
+        <p14:creationId xmlns:p14="http://schemas.microsoft.com/office/powerpoint/2010/main" val="812308775"/>
       </p:ext>
     </p:extLst>
   </p:cSld>
@@ -1163,7 +1275,7 @@
           <a:p>
             <a:r>
               <a:rPr lang="en-US" dirty="0"/>
-              <a:t>[Terrence] Say this framing first: "A tutor might point at a specific arrow on our sequence diagram and ask, show me exactly where this happens in the code. Here is how we would answer that, for the chemical spill story." Then go down the table, and for at least the first two rows, actually open the file and show the matching line, so it is not just a slide claim.</a:t>
+              <a:t>[Terrence] Keep this concrete and physical. "Whoever creates a command with new also hands it to the console, and from that point the console is responsible for deleting it, whether it fails immediately, gets undone later, or the program simply ends." Then the trickier one: "An incident owns its own current stage. The tricky part is, a stage sometimes has to replace itself while it is still running. We do not delete a stage while it is still in the middle of running its own code, we wait until it finishes, and only then swap it out safely." Finish simply: "Everything else, the mediator, the door system, the strategies, is just being borrowed. Whoever created it on the stack in main is the one who cleans it up."</a:t>
             </a:r>
           </a:p>
         </p:txBody>
@@ -1846,6 +1958,1222 @@
 
 <file path=ppt/slides/slide10.xml><?xml version="1.0" encoding="utf-8"?>
 <p:sld xmlns:a="http://schemas.openxmlformats.org/drawingml/2006/main" xmlns:r="http://schemas.openxmlformats.org/officeDocument/2006/relationships" xmlns:p="http://schemas.openxmlformats.org/presentationml/2006/main">
+  <p:cSld name="Slide 9">
+    <p:bg>
+      <p:bgPr>
+        <a:solidFill>
+          <a:srgbClr val="FFFFFF"/>
+        </a:solidFill>
+        <a:effectLst/>
+      </p:bgPr>
+    </p:bg>
+    <p:spTree>
+      <p:nvGrpSpPr>
+        <p:cNvPr id="1" name=""/>
+        <p:cNvGrpSpPr/>
+        <p:nvPr/>
+      </p:nvGrpSpPr>
+      <p:grpSpPr>
+        <a:xfrm>
+          <a:off x="0" y="0"/>
+          <a:ext cx="0" cy="0"/>
+          <a:chOff x="0" y="0"/>
+          <a:chExt cx="0" cy="0"/>
+        </a:xfrm>
+      </p:grpSpPr>
+      <p:sp>
+        <p:nvSpPr>
+          <p:cNvPr id="2" name="Text 0"/>
+          <p:cNvSpPr txBox="1"/>
+          <p:nvPr/>
+        </p:nvSpPr>
+        <p:spPr>
+          <a:xfrm>
+            <a:off x="457200" y="274320"/>
+            <a:ext cx="8229600" cy="548640"/>
+          </a:xfrm>
+          <a:prstGeom prst="rect">
+            <a:avLst/>
+          </a:prstGeom>
+          <a:noFill/>
+          <a:ln/>
+        </p:spPr>
+        <p:txBody>
+          <a:bodyPr wrap="square" lIns="0" tIns="0" rIns="0" bIns="0" rtlCol="0" anchor="ctr"/>
+          <a:lstStyle/>
+          <a:p>
+            <a:pPr marL="0" indent="0">
+              <a:buNone/>
+            </a:pPr>
+            <a:r>
+              <a:rPr lang="en-US" sz="2500" b="1" dirty="0">
+                <a:solidFill>
+                  <a:srgbClr val="1F2A44"/>
+                </a:solidFill>
+                <a:latin typeface="Calibri" pitchFamily="34" charset="0"/>
+                <a:ea typeface="Calibri" pitchFamily="34" charset="-122"/>
+                <a:cs typeface="Calibri" pitchFamily="34" charset="-120"/>
+              </a:rPr>
+              <a:t>9. Matching our diagrams to our actual code</a:t>
+            </a:r>
+            <a:endParaRPr lang="en-US" sz="2500" dirty="0"/>
+          </a:p>
+        </p:txBody>
+      </p:sp>
+      <p:graphicFrame>
+        <p:nvGraphicFramePr>
+          <p:cNvPr id="10" name="Table 0"/>
+          <p:cNvGraphicFramePr>
+            <a:graphicFrameLocks noGrp="1"/>
+          </p:cNvGraphicFramePr>
+          <p:nvPr>
+            <p:extLst>
+              <p:ext uri="{D42A27DB-BD31-4B8C-83A1-F6EECF244321}">
+                <p14:modId xmlns:p14="http://schemas.microsoft.com/office/powerpoint/2010/main" val="1579011935"/>
+              </p:ext>
+            </p:extLst>
+          </p:nvPr>
+        </p:nvGraphicFramePr>
+        <p:xfrm>
+          <a:off x="457200" y="1005840"/>
+          <a:ext cx="8229600" cy="2816352"/>
+        </p:xfrm>
+        <a:graphic>
+          <a:graphicData uri="http://schemas.openxmlformats.org/drawingml/2006/table">
+            <a:tbl>
+              <a:tblPr/>
+              <a:tblGrid>
+                <a:gridCol w="4572000">
+                  <a:extLst>
+                    <a:ext uri="{9D8B030D-6E8A-4147-A177-3AD203B41FA5}">
+                      <a16:colId xmlns:a16="http://schemas.microsoft.com/office/drawing/2014/main" val="20000"/>
+                    </a:ext>
+                  </a:extLst>
+                </a:gridCol>
+                <a:gridCol w="3657600">
+                  <a:extLst>
+                    <a:ext uri="{9D8B030D-6E8A-4147-A177-3AD203B41FA5}">
+                      <a16:colId xmlns:a16="http://schemas.microsoft.com/office/drawing/2014/main" val="20001"/>
+                    </a:ext>
+                  </a:extLst>
+                </a:gridCol>
+              </a:tblGrid>
+              <a:tr h="0">
+                <a:tc>
+                  <a:txBody>
+                    <a:bodyPr/>
+                    <a:lstStyle/>
+                    <a:p>
+                      <a:pPr marL="0" indent="0">
+                        <a:buNone/>
+                      </a:pPr>
+                      <a:r>
+                        <a:rPr lang="en-US" sz="1200" b="1" dirty="0">
+                          <a:solidFill>
+                            <a:srgbClr val="FFFFFF"/>
+                          </a:solidFill>
+                          <a:latin typeface="Calibri" pitchFamily="34" charset="0"/>
+                          <a:ea typeface="Calibri" pitchFamily="34" charset="-122"/>
+                          <a:cs typeface="Calibri" pitchFamily="34" charset="-120"/>
+                        </a:rPr>
+                        <a:t>Arrow on the sequence diagram</a:t>
+                      </a:r>
+                      <a:endParaRPr lang="en-US" sz="1200" dirty="0">
+                        <a:latin typeface="Calibri" charset="0"/>
+                        <a:ea typeface="Calibri" charset="0"/>
+                        <a:cs typeface="Calibri" charset="0"/>
+                      </a:endParaRPr>
+                    </a:p>
+                  </a:txBody>
+                  <a:tcPr marL="73152" marR="73152" marT="73152" marB="73152" anchor="ctr">
+                    <a:lnL w="12700" cap="flat" cmpd="sng" algn="ctr">
+                      <a:solidFill>
+                        <a:srgbClr val="D5DDE8"/>
+                      </a:solidFill>
+                      <a:prstDash val="solid"/>
+                      <a:round/>
+                      <a:headEnd type="none" w="med" len="med"/>
+                      <a:tailEnd type="none" w="med" len="med"/>
+                    </a:lnL>
+                    <a:lnR w="12700" cap="flat" cmpd="sng" algn="ctr">
+                      <a:solidFill>
+                        <a:srgbClr val="D5DDE8"/>
+                      </a:solidFill>
+                      <a:prstDash val="solid"/>
+                      <a:round/>
+                      <a:headEnd type="none" w="med" len="med"/>
+                      <a:tailEnd type="none" w="med" len="med"/>
+                    </a:lnR>
+                    <a:lnT w="12700" cap="flat" cmpd="sng" algn="ctr">
+                      <a:solidFill>
+                        <a:srgbClr val="D5DDE8"/>
+                      </a:solidFill>
+                      <a:prstDash val="solid"/>
+                      <a:round/>
+                      <a:headEnd type="none" w="med" len="med"/>
+                      <a:tailEnd type="none" w="med" len="med"/>
+                    </a:lnT>
+                    <a:lnB w="12700" cap="flat" cmpd="sng" algn="ctr">
+                      <a:solidFill>
+                        <a:srgbClr val="D5DDE8"/>
+                      </a:solidFill>
+                      <a:prstDash val="solid"/>
+                      <a:round/>
+                      <a:headEnd type="none" w="med" len="med"/>
+                      <a:tailEnd type="none" w="med" len="med"/>
+                    </a:lnB>
+                    <a:solidFill>
+                      <a:srgbClr val="1F2A44"/>
+                    </a:solidFill>
+                  </a:tcPr>
+                </a:tc>
+                <a:tc>
+                  <a:txBody>
+                    <a:bodyPr/>
+                    <a:lstStyle/>
+                    <a:p>
+                      <a:pPr marL="0" indent="0">
+                        <a:buNone/>
+                      </a:pPr>
+                      <a:r>
+                        <a:rPr lang="en-US" sz="1200" b="1" dirty="0">
+                          <a:solidFill>
+                            <a:srgbClr val="FFFFFF"/>
+                          </a:solidFill>
+                          <a:latin typeface="Calibri" pitchFamily="34" charset="0"/>
+                          <a:ea typeface="Calibri" pitchFamily="34" charset="-122"/>
+                          <a:cs typeface="Calibri" pitchFamily="34" charset="-120"/>
+                        </a:rPr>
+                        <a:t>Where it actually happens in our code</a:t>
+                      </a:r>
+                      <a:endParaRPr lang="en-US" sz="1200" dirty="0">
+                        <a:latin typeface="Calibri" charset="0"/>
+                        <a:ea typeface="Calibri" charset="0"/>
+                        <a:cs typeface="Calibri" charset="0"/>
+                      </a:endParaRPr>
+                    </a:p>
+                  </a:txBody>
+                  <a:tcPr marL="73152" marR="73152" marT="73152" marB="73152" anchor="ctr">
+                    <a:lnL w="12700" cap="flat" cmpd="sng" algn="ctr">
+                      <a:solidFill>
+                        <a:srgbClr val="D5DDE8"/>
+                      </a:solidFill>
+                      <a:prstDash val="solid"/>
+                      <a:round/>
+                      <a:headEnd type="none" w="med" len="med"/>
+                      <a:tailEnd type="none" w="med" len="med"/>
+                    </a:lnL>
+                    <a:lnR w="12700" cap="flat" cmpd="sng" algn="ctr">
+                      <a:solidFill>
+                        <a:srgbClr val="D5DDE8"/>
+                      </a:solidFill>
+                      <a:prstDash val="solid"/>
+                      <a:round/>
+                      <a:headEnd type="none" w="med" len="med"/>
+                      <a:tailEnd type="none" w="med" len="med"/>
+                    </a:lnR>
+                    <a:lnT w="12700" cap="flat" cmpd="sng" algn="ctr">
+                      <a:solidFill>
+                        <a:srgbClr val="D5DDE8"/>
+                      </a:solidFill>
+                      <a:prstDash val="solid"/>
+                      <a:round/>
+                      <a:headEnd type="none" w="med" len="med"/>
+                      <a:tailEnd type="none" w="med" len="med"/>
+                    </a:lnT>
+                    <a:lnB w="12700" cap="flat" cmpd="sng" algn="ctr">
+                      <a:solidFill>
+                        <a:srgbClr val="D5DDE8"/>
+                      </a:solidFill>
+                      <a:prstDash val="solid"/>
+                      <a:round/>
+                      <a:headEnd type="none" w="med" len="med"/>
+                      <a:tailEnd type="none" w="med" len="med"/>
+                    </a:lnB>
+                    <a:solidFill>
+                      <a:srgbClr val="1F2A44"/>
+                    </a:solidFill>
+                  </a:tcPr>
+                </a:tc>
+                <a:extLst>
+                  <a:ext uri="{0D108BD9-81ED-4DB2-BD59-A6C34878D82A}">
+                    <a16:rowId xmlns:a16="http://schemas.microsoft.com/office/drawing/2014/main" val="10000"/>
+                  </a:ext>
+                </a:extLst>
+              </a:tr>
+              <a:tr h="0">
+                <a:tc>
+                  <a:txBody>
+                    <a:bodyPr/>
+                    <a:lstStyle/>
+                    <a:p>
+                      <a:pPr marL="0" indent="0">
+                        <a:buNone/>
+                      </a:pPr>
+                      <a:r>
+                        <a:rPr lang="en-US" sz="1200" b="1" dirty="0">
+                          <a:solidFill>
+                            <a:srgbClr val="1F2A44"/>
+                          </a:solidFill>
+                          <a:latin typeface="Calibri" pitchFamily="34" charset="0"/>
+                          <a:ea typeface="Calibri" pitchFamily="34" charset="-122"/>
+                          <a:cs typeface="Calibri" pitchFamily="34" charset="-120"/>
+                        </a:rPr>
+                        <a:t>Operator calls the chemical spill protocol</a:t>
+                      </a:r>
+                      <a:endParaRPr lang="en-US" sz="1200" dirty="0">
+                        <a:latin typeface="Calibri" charset="0"/>
+                        <a:ea typeface="Calibri" charset="0"/>
+                        <a:cs typeface="Calibri" charset="0"/>
+                      </a:endParaRPr>
+                    </a:p>
+                  </a:txBody>
+                  <a:tcPr marL="73152" marR="73152" marT="73152" marB="73152" anchor="ctr">
+                    <a:lnL w="12700" cap="flat" cmpd="sng" algn="ctr">
+                      <a:solidFill>
+                        <a:srgbClr val="D5DDE8"/>
+                      </a:solidFill>
+                      <a:prstDash val="solid"/>
+                      <a:round/>
+                      <a:headEnd type="none" w="med" len="med"/>
+                      <a:tailEnd type="none" w="med" len="med"/>
+                    </a:lnL>
+                    <a:lnR w="12700" cap="flat" cmpd="sng" algn="ctr">
+                      <a:solidFill>
+                        <a:srgbClr val="D5DDE8"/>
+                      </a:solidFill>
+                      <a:prstDash val="solid"/>
+                      <a:round/>
+                      <a:headEnd type="none" w="med" len="med"/>
+                      <a:tailEnd type="none" w="med" len="med"/>
+                    </a:lnR>
+                    <a:lnT w="12700" cap="flat" cmpd="sng" algn="ctr">
+                      <a:solidFill>
+                        <a:srgbClr val="D5DDE8"/>
+                      </a:solidFill>
+                      <a:prstDash val="solid"/>
+                      <a:round/>
+                      <a:headEnd type="none" w="med" len="med"/>
+                      <a:tailEnd type="none" w="med" len="med"/>
+                    </a:lnT>
+                    <a:lnB w="12700" cap="flat" cmpd="sng" algn="ctr">
+                      <a:solidFill>
+                        <a:srgbClr val="D5DDE8"/>
+                      </a:solidFill>
+                      <a:prstDash val="solid"/>
+                      <a:round/>
+                      <a:headEnd type="none" w="med" len="med"/>
+                      <a:tailEnd type="none" w="med" len="med"/>
+                    </a:lnB>
+                  </a:tcPr>
+                </a:tc>
+                <a:tc>
+                  <a:txBody>
+                    <a:bodyPr/>
+                    <a:lstStyle/>
+                    <a:p>
+                      <a:pPr marL="0" indent="0">
+                        <a:buNone/>
+                      </a:pPr>
+                      <a:r>
+                        <a:rPr lang="en-US" sz="1200" dirty="0">
+                          <a:solidFill>
+                            <a:srgbClr val="1F2A44"/>
+                          </a:solidFill>
+                          <a:latin typeface="Calibri" pitchFamily="34" charset="0"/>
+                          <a:ea typeface="Calibri" pitchFamily="34" charset="-122"/>
+                          <a:cs typeface="Calibri" pitchFamily="34" charset="-120"/>
+                        </a:rPr>
+                        <a:t>CampusEmergencyFacade.cpp, handleChemicalSpillProtocol</a:t>
+                      </a:r>
+                      <a:endParaRPr lang="en-US" sz="1200" dirty="0">
+                        <a:latin typeface="Calibri" charset="0"/>
+                        <a:ea typeface="Calibri" charset="0"/>
+                        <a:cs typeface="Calibri" charset="0"/>
+                      </a:endParaRPr>
+                    </a:p>
+                  </a:txBody>
+                  <a:tcPr marL="73152" marR="73152" marT="73152" marB="73152" anchor="ctr">
+                    <a:lnL w="12700" cap="flat" cmpd="sng" algn="ctr">
+                      <a:solidFill>
+                        <a:srgbClr val="D5DDE8"/>
+                      </a:solidFill>
+                      <a:prstDash val="solid"/>
+                      <a:round/>
+                      <a:headEnd type="none" w="med" len="med"/>
+                      <a:tailEnd type="none" w="med" len="med"/>
+                    </a:lnL>
+                    <a:lnR w="12700" cap="flat" cmpd="sng" algn="ctr">
+                      <a:solidFill>
+                        <a:srgbClr val="D5DDE8"/>
+                      </a:solidFill>
+                      <a:prstDash val="solid"/>
+                      <a:round/>
+                      <a:headEnd type="none" w="med" len="med"/>
+                      <a:tailEnd type="none" w="med" len="med"/>
+                    </a:lnR>
+                    <a:lnT w="12700" cap="flat" cmpd="sng" algn="ctr">
+                      <a:solidFill>
+                        <a:srgbClr val="D5DDE8"/>
+                      </a:solidFill>
+                      <a:prstDash val="solid"/>
+                      <a:round/>
+                      <a:headEnd type="none" w="med" len="med"/>
+                      <a:tailEnd type="none" w="med" len="med"/>
+                    </a:lnT>
+                    <a:lnB w="12700" cap="flat" cmpd="sng" algn="ctr">
+                      <a:solidFill>
+                        <a:srgbClr val="D5DDE8"/>
+                      </a:solidFill>
+                      <a:prstDash val="solid"/>
+                      <a:round/>
+                      <a:headEnd type="none" w="med" len="med"/>
+                      <a:tailEnd type="none" w="med" len="med"/>
+                    </a:lnB>
+                  </a:tcPr>
+                </a:tc>
+                <a:extLst>
+                  <a:ext uri="{0D108BD9-81ED-4DB2-BD59-A6C34878D82A}">
+                    <a16:rowId xmlns:a16="http://schemas.microsoft.com/office/drawing/2014/main" val="10001"/>
+                  </a:ext>
+                </a:extLst>
+              </a:tr>
+              <a:tr h="0">
+                <a:tc>
+                  <a:txBody>
+                    <a:bodyPr/>
+                    <a:lstStyle/>
+                    <a:p>
+                      <a:pPr marL="0" indent="0">
+                        <a:buNone/>
+                      </a:pPr>
+                      <a:r>
+                        <a:rPr lang="en-US" sz="1200" b="1" dirty="0">
+                          <a:solidFill>
+                            <a:srgbClr val="1F2A44"/>
+                          </a:solidFill>
+                          <a:latin typeface="Calibri" pitchFamily="34" charset="0"/>
+                          <a:ea typeface="Calibri" pitchFamily="34" charset="-122"/>
+                          <a:cs typeface="Calibri" pitchFamily="34" charset="-120"/>
+                        </a:rPr>
+                        <a:t>Console is asked to run the command</a:t>
+                      </a:r>
+                      <a:endParaRPr lang="en-US" sz="1200" dirty="0">
+                        <a:latin typeface="Calibri" charset="0"/>
+                        <a:ea typeface="Calibri" charset="0"/>
+                        <a:cs typeface="Calibri" charset="0"/>
+                      </a:endParaRPr>
+                    </a:p>
+                  </a:txBody>
+                  <a:tcPr marL="73152" marR="73152" marT="73152" marB="73152" anchor="ctr">
+                    <a:lnL w="12700" cap="flat" cmpd="sng" algn="ctr">
+                      <a:solidFill>
+                        <a:srgbClr val="D5DDE8"/>
+                      </a:solidFill>
+                      <a:prstDash val="solid"/>
+                      <a:round/>
+                      <a:headEnd type="none" w="med" len="med"/>
+                      <a:tailEnd type="none" w="med" len="med"/>
+                    </a:lnL>
+                    <a:lnR w="12700" cap="flat" cmpd="sng" algn="ctr">
+                      <a:solidFill>
+                        <a:srgbClr val="D5DDE8"/>
+                      </a:solidFill>
+                      <a:prstDash val="solid"/>
+                      <a:round/>
+                      <a:headEnd type="none" w="med" len="med"/>
+                      <a:tailEnd type="none" w="med" len="med"/>
+                    </a:lnR>
+                    <a:lnT w="12700" cap="flat" cmpd="sng" algn="ctr">
+                      <a:solidFill>
+                        <a:srgbClr val="D5DDE8"/>
+                      </a:solidFill>
+                      <a:prstDash val="solid"/>
+                      <a:round/>
+                      <a:headEnd type="none" w="med" len="med"/>
+                      <a:tailEnd type="none" w="med" len="med"/>
+                    </a:lnT>
+                    <a:lnB w="12700" cap="flat" cmpd="sng" algn="ctr">
+                      <a:solidFill>
+                        <a:srgbClr val="D5DDE8"/>
+                      </a:solidFill>
+                      <a:prstDash val="solid"/>
+                      <a:round/>
+                      <a:headEnd type="none" w="med" len="med"/>
+                      <a:tailEnd type="none" w="med" len="med"/>
+                    </a:lnB>
+                  </a:tcPr>
+                </a:tc>
+                <a:tc>
+                  <a:txBody>
+                    <a:bodyPr/>
+                    <a:lstStyle/>
+                    <a:p>
+                      <a:pPr marL="0" indent="0">
+                        <a:buNone/>
+                      </a:pPr>
+                      <a:r>
+                        <a:rPr lang="en-US" sz="1200" dirty="0">
+                          <a:solidFill>
+                            <a:srgbClr val="1F2A44"/>
+                          </a:solidFill>
+                          <a:latin typeface="Calibri" pitchFamily="34" charset="0"/>
+                          <a:ea typeface="Calibri" pitchFamily="34" charset="-122"/>
+                          <a:cs typeface="Calibri" pitchFamily="34" charset="-120"/>
+                        </a:rPr>
+                        <a:t>OperatorConsole::executeCommand</a:t>
+                      </a:r>
+                      <a:endParaRPr lang="en-US" sz="1200" dirty="0">
+                        <a:latin typeface="Calibri" charset="0"/>
+                        <a:ea typeface="Calibri" charset="0"/>
+                        <a:cs typeface="Calibri" charset="0"/>
+                      </a:endParaRPr>
+                    </a:p>
+                  </a:txBody>
+                  <a:tcPr marL="73152" marR="73152" marT="73152" marB="73152" anchor="ctr">
+                    <a:lnL w="12700" cap="flat" cmpd="sng" algn="ctr">
+                      <a:solidFill>
+                        <a:srgbClr val="D5DDE8"/>
+                      </a:solidFill>
+                      <a:prstDash val="solid"/>
+                      <a:round/>
+                      <a:headEnd type="none" w="med" len="med"/>
+                      <a:tailEnd type="none" w="med" len="med"/>
+                    </a:lnL>
+                    <a:lnR w="12700" cap="flat" cmpd="sng" algn="ctr">
+                      <a:solidFill>
+                        <a:srgbClr val="D5DDE8"/>
+                      </a:solidFill>
+                      <a:prstDash val="solid"/>
+                      <a:round/>
+                      <a:headEnd type="none" w="med" len="med"/>
+                      <a:tailEnd type="none" w="med" len="med"/>
+                    </a:lnR>
+                    <a:lnT w="12700" cap="flat" cmpd="sng" algn="ctr">
+                      <a:solidFill>
+                        <a:srgbClr val="D5DDE8"/>
+                      </a:solidFill>
+                      <a:prstDash val="solid"/>
+                      <a:round/>
+                      <a:headEnd type="none" w="med" len="med"/>
+                      <a:tailEnd type="none" w="med" len="med"/>
+                    </a:lnT>
+                    <a:lnB w="12700" cap="flat" cmpd="sng" algn="ctr">
+                      <a:solidFill>
+                        <a:srgbClr val="D5DDE8"/>
+                      </a:solidFill>
+                      <a:prstDash val="solid"/>
+                      <a:round/>
+                      <a:headEnd type="none" w="med" len="med"/>
+                      <a:tailEnd type="none" w="med" len="med"/>
+                    </a:lnB>
+                  </a:tcPr>
+                </a:tc>
+                <a:extLst>
+                  <a:ext uri="{0D108BD9-81ED-4DB2-BD59-A6C34878D82A}">
+                    <a16:rowId xmlns:a16="http://schemas.microsoft.com/office/drawing/2014/main" val="10002"/>
+                  </a:ext>
+                </a:extLst>
+              </a:tr>
+              <a:tr h="0">
+                <a:tc>
+                  <a:txBody>
+                    <a:bodyPr/>
+                    <a:lstStyle/>
+                    <a:p>
+                      <a:pPr marL="0" indent="0">
+                        <a:buNone/>
+                      </a:pPr>
+                      <a:r>
+                        <a:rPr lang="en-US" sz="1200" b="1" dirty="0">
+                          <a:solidFill>
+                            <a:srgbClr val="1F2A44"/>
+                          </a:solidFill>
+                          <a:latin typeface="Calibri" pitchFamily="34" charset="0"/>
+                          <a:ea typeface="Calibri" pitchFamily="34" charset="-122"/>
+                          <a:cs typeface="Calibri" pitchFamily="34" charset="-120"/>
+                        </a:rPr>
+                        <a:t>Command is executed</a:t>
+                      </a:r>
+                      <a:endParaRPr lang="en-US" sz="1200" dirty="0">
+                        <a:latin typeface="Calibri" charset="0"/>
+                        <a:ea typeface="Calibri" charset="0"/>
+                        <a:cs typeface="Calibri" charset="0"/>
+                      </a:endParaRPr>
+                    </a:p>
+                  </a:txBody>
+                  <a:tcPr marL="73152" marR="73152" marT="73152" marB="73152" anchor="ctr">
+                    <a:lnL w="12700" cap="flat" cmpd="sng" algn="ctr">
+                      <a:solidFill>
+                        <a:srgbClr val="D5DDE8"/>
+                      </a:solidFill>
+                      <a:prstDash val="solid"/>
+                      <a:round/>
+                      <a:headEnd type="none" w="med" len="med"/>
+                      <a:tailEnd type="none" w="med" len="med"/>
+                    </a:lnL>
+                    <a:lnR w="12700" cap="flat" cmpd="sng" algn="ctr">
+                      <a:solidFill>
+                        <a:srgbClr val="D5DDE8"/>
+                      </a:solidFill>
+                      <a:prstDash val="solid"/>
+                      <a:round/>
+                      <a:headEnd type="none" w="med" len="med"/>
+                      <a:tailEnd type="none" w="med" len="med"/>
+                    </a:lnR>
+                    <a:lnT w="12700" cap="flat" cmpd="sng" algn="ctr">
+                      <a:solidFill>
+                        <a:srgbClr val="D5DDE8"/>
+                      </a:solidFill>
+                      <a:prstDash val="solid"/>
+                      <a:round/>
+                      <a:headEnd type="none" w="med" len="med"/>
+                      <a:tailEnd type="none" w="med" len="med"/>
+                    </a:lnT>
+                    <a:lnB w="12700" cap="flat" cmpd="sng" algn="ctr">
+                      <a:solidFill>
+                        <a:srgbClr val="D5DDE8"/>
+                      </a:solidFill>
+                      <a:prstDash val="solid"/>
+                      <a:round/>
+                      <a:headEnd type="none" w="med" len="med"/>
+                      <a:tailEnd type="none" w="med" len="med"/>
+                    </a:lnB>
+                  </a:tcPr>
+                </a:tc>
+                <a:tc>
+                  <a:txBody>
+                    <a:bodyPr/>
+                    <a:lstStyle/>
+                    <a:p>
+                      <a:pPr marL="0" indent="0">
+                        <a:buNone/>
+                      </a:pPr>
+                      <a:r>
+                        <a:rPr lang="en-US" sz="1200" dirty="0">
+                          <a:solidFill>
+                            <a:srgbClr val="1F2A44"/>
+                          </a:solidFill>
+                          <a:latin typeface="Calibri" pitchFamily="34" charset="0"/>
+                          <a:ea typeface="Calibri" pitchFamily="34" charset="-122"/>
+                          <a:cs typeface="Calibri" pitchFamily="34" charset="-120"/>
+                        </a:rPr>
+                        <a:t>ApplyStrategyCommand::execute</a:t>
+                      </a:r>
+                      <a:endParaRPr lang="en-US" sz="1200" dirty="0">
+                        <a:latin typeface="Calibri" charset="0"/>
+                        <a:ea typeface="Calibri" charset="0"/>
+                        <a:cs typeface="Calibri" charset="0"/>
+                      </a:endParaRPr>
+                    </a:p>
+                  </a:txBody>
+                  <a:tcPr marL="73152" marR="73152" marT="73152" marB="73152" anchor="ctr">
+                    <a:lnL w="12700" cap="flat" cmpd="sng" algn="ctr">
+                      <a:solidFill>
+                        <a:srgbClr val="D5DDE8"/>
+                      </a:solidFill>
+                      <a:prstDash val="solid"/>
+                      <a:round/>
+                      <a:headEnd type="none" w="med" len="med"/>
+                      <a:tailEnd type="none" w="med" len="med"/>
+                    </a:lnL>
+                    <a:lnR w="12700" cap="flat" cmpd="sng" algn="ctr">
+                      <a:solidFill>
+                        <a:srgbClr val="D5DDE8"/>
+                      </a:solidFill>
+                      <a:prstDash val="solid"/>
+                      <a:round/>
+                      <a:headEnd type="none" w="med" len="med"/>
+                      <a:tailEnd type="none" w="med" len="med"/>
+                    </a:lnR>
+                    <a:lnT w="12700" cap="flat" cmpd="sng" algn="ctr">
+                      <a:solidFill>
+                        <a:srgbClr val="D5DDE8"/>
+                      </a:solidFill>
+                      <a:prstDash val="solid"/>
+                      <a:round/>
+                      <a:headEnd type="none" w="med" len="med"/>
+                      <a:tailEnd type="none" w="med" len="med"/>
+                    </a:lnT>
+                    <a:lnB w="12700" cap="flat" cmpd="sng" algn="ctr">
+                      <a:solidFill>
+                        <a:srgbClr val="D5DDE8"/>
+                      </a:solidFill>
+                      <a:prstDash val="solid"/>
+                      <a:round/>
+                      <a:headEnd type="none" w="med" len="med"/>
+                      <a:tailEnd type="none" w="med" len="med"/>
+                    </a:lnB>
+                  </a:tcPr>
+                </a:tc>
+                <a:extLst>
+                  <a:ext uri="{0D108BD9-81ED-4DB2-BD59-A6C34878D82A}">
+                    <a16:rowId xmlns:a16="http://schemas.microsoft.com/office/drawing/2014/main" val="10003"/>
+                  </a:ext>
+                </a:extLst>
+              </a:tr>
+              <a:tr h="0">
+                <a:tc>
+                  <a:txBody>
+                    <a:bodyPr/>
+                    <a:lstStyle/>
+                    <a:p>
+                      <a:pPr marL="0" indent="0">
+                        <a:buNone/>
+                      </a:pPr>
+                      <a:r>
+                        <a:rPr lang="en-US" sz="1200" b="1" dirty="0">
+                          <a:solidFill>
+                            <a:srgbClr val="1F2A44"/>
+                          </a:solidFill>
+                          <a:latin typeface="Calibri" pitchFamily="34" charset="0"/>
+                          <a:ea typeface="Calibri" pitchFamily="34" charset="-122"/>
+                          <a:cs typeface="Calibri" pitchFamily="34" charset="-120"/>
+                        </a:rPr>
+                        <a:t>Incident is told to dispatch responders</a:t>
+                      </a:r>
+                      <a:endParaRPr lang="en-US" sz="1200" dirty="0">
+                        <a:latin typeface="Calibri" charset="0"/>
+                        <a:ea typeface="Calibri" charset="0"/>
+                        <a:cs typeface="Calibri" charset="0"/>
+                      </a:endParaRPr>
+                    </a:p>
+                  </a:txBody>
+                  <a:tcPr marL="73152" marR="73152" marT="73152" marB="73152" anchor="ctr">
+                    <a:lnL w="12700" cap="flat" cmpd="sng" algn="ctr">
+                      <a:solidFill>
+                        <a:srgbClr val="D5DDE8"/>
+                      </a:solidFill>
+                      <a:prstDash val="solid"/>
+                      <a:round/>
+                      <a:headEnd type="none" w="med" len="med"/>
+                      <a:tailEnd type="none" w="med" len="med"/>
+                    </a:lnL>
+                    <a:lnR w="12700" cap="flat" cmpd="sng" algn="ctr">
+                      <a:solidFill>
+                        <a:srgbClr val="D5DDE8"/>
+                      </a:solidFill>
+                      <a:prstDash val="solid"/>
+                      <a:round/>
+                      <a:headEnd type="none" w="med" len="med"/>
+                      <a:tailEnd type="none" w="med" len="med"/>
+                    </a:lnR>
+                    <a:lnT w="12700" cap="flat" cmpd="sng" algn="ctr">
+                      <a:solidFill>
+                        <a:srgbClr val="D5DDE8"/>
+                      </a:solidFill>
+                      <a:prstDash val="solid"/>
+                      <a:round/>
+                      <a:headEnd type="none" w="med" len="med"/>
+                      <a:tailEnd type="none" w="med" len="med"/>
+                    </a:lnT>
+                    <a:lnB w="12700" cap="flat" cmpd="sng" algn="ctr">
+                      <a:solidFill>
+                        <a:srgbClr val="D5DDE8"/>
+                      </a:solidFill>
+                      <a:prstDash val="solid"/>
+                      <a:round/>
+                      <a:headEnd type="none" w="med" len="med"/>
+                      <a:tailEnd type="none" w="med" len="med"/>
+                    </a:lnB>
+                  </a:tcPr>
+                </a:tc>
+                <a:tc>
+                  <a:txBody>
+                    <a:bodyPr/>
+                    <a:lstStyle/>
+                    <a:p>
+                      <a:pPr marL="0" indent="0">
+                        <a:buNone/>
+                      </a:pPr>
+                      <a:r>
+                        <a:rPr lang="en-US" sz="1200" dirty="0">
+                          <a:solidFill>
+                            <a:srgbClr val="1F2A44"/>
+                          </a:solidFill>
+                          <a:latin typeface="Calibri" pitchFamily="34" charset="0"/>
+                          <a:ea typeface="Calibri" pitchFamily="34" charset="-122"/>
+                          <a:cs typeface="Calibri" pitchFamily="34" charset="-120"/>
+                        </a:rPr>
+                        <a:t>Incident::dispatchResponders</a:t>
+                      </a:r>
+                      <a:endParaRPr lang="en-US" sz="1200" dirty="0">
+                        <a:latin typeface="Calibri" charset="0"/>
+                        <a:ea typeface="Calibri" charset="0"/>
+                        <a:cs typeface="Calibri" charset="0"/>
+                      </a:endParaRPr>
+                    </a:p>
+                  </a:txBody>
+                  <a:tcPr marL="73152" marR="73152" marT="73152" marB="73152" anchor="ctr">
+                    <a:lnL w="12700" cap="flat" cmpd="sng" algn="ctr">
+                      <a:solidFill>
+                        <a:srgbClr val="D5DDE8"/>
+                      </a:solidFill>
+                      <a:prstDash val="solid"/>
+                      <a:round/>
+                      <a:headEnd type="none" w="med" len="med"/>
+                      <a:tailEnd type="none" w="med" len="med"/>
+                    </a:lnL>
+                    <a:lnR w="12700" cap="flat" cmpd="sng" algn="ctr">
+                      <a:solidFill>
+                        <a:srgbClr val="D5DDE8"/>
+                      </a:solidFill>
+                      <a:prstDash val="solid"/>
+                      <a:round/>
+                      <a:headEnd type="none" w="med" len="med"/>
+                      <a:tailEnd type="none" w="med" len="med"/>
+                    </a:lnR>
+                    <a:lnT w="12700" cap="flat" cmpd="sng" algn="ctr">
+                      <a:solidFill>
+                        <a:srgbClr val="D5DDE8"/>
+                      </a:solidFill>
+                      <a:prstDash val="solid"/>
+                      <a:round/>
+                      <a:headEnd type="none" w="med" len="med"/>
+                      <a:tailEnd type="none" w="med" len="med"/>
+                    </a:lnT>
+                    <a:lnB w="12700" cap="flat" cmpd="sng" algn="ctr">
+                      <a:solidFill>
+                        <a:srgbClr val="D5DDE8"/>
+                      </a:solidFill>
+                      <a:prstDash val="solid"/>
+                      <a:round/>
+                      <a:headEnd type="none" w="med" len="med"/>
+                      <a:tailEnd type="none" w="med" len="med"/>
+                    </a:lnB>
+                  </a:tcPr>
+                </a:tc>
+                <a:extLst>
+                  <a:ext uri="{0D108BD9-81ED-4DB2-BD59-A6C34878D82A}">
+                    <a16:rowId xmlns:a16="http://schemas.microsoft.com/office/drawing/2014/main" val="10004"/>
+                  </a:ext>
+                </a:extLst>
+              </a:tr>
+              <a:tr h="0">
+                <a:tc>
+                  <a:txBody>
+                    <a:bodyPr/>
+                    <a:lstStyle/>
+                    <a:p>
+                      <a:pPr marL="0" indent="0">
+                        <a:buNone/>
+                      </a:pPr>
+                      <a:r>
+                        <a:rPr lang="en-US" sz="1200" b="1" dirty="0">
+                          <a:solidFill>
+                            <a:srgbClr val="1F2A44"/>
+                          </a:solidFill>
+                          <a:latin typeface="Calibri" pitchFamily="34" charset="0"/>
+                          <a:ea typeface="Calibri" pitchFamily="34" charset="-122"/>
+                          <a:cs typeface="Calibri" pitchFamily="34" charset="-120"/>
+                        </a:rPr>
+                        <a:t>The chosen tactic actually runs</a:t>
+                      </a:r>
+                      <a:endParaRPr lang="en-US" sz="1200" dirty="0">
+                        <a:latin typeface="Calibri" charset="0"/>
+                        <a:ea typeface="Calibri" charset="0"/>
+                        <a:cs typeface="Calibri" charset="0"/>
+                      </a:endParaRPr>
+                    </a:p>
+                  </a:txBody>
+                  <a:tcPr marL="73152" marR="73152" marT="73152" marB="73152" anchor="ctr">
+                    <a:lnL w="12700" cap="flat" cmpd="sng" algn="ctr">
+                      <a:solidFill>
+                        <a:srgbClr val="D5DDE8"/>
+                      </a:solidFill>
+                      <a:prstDash val="solid"/>
+                      <a:round/>
+                      <a:headEnd type="none" w="med" len="med"/>
+                      <a:tailEnd type="none" w="med" len="med"/>
+                    </a:lnL>
+                    <a:lnR w="12700" cap="flat" cmpd="sng" algn="ctr">
+                      <a:solidFill>
+                        <a:srgbClr val="D5DDE8"/>
+                      </a:solidFill>
+                      <a:prstDash val="solid"/>
+                      <a:round/>
+                      <a:headEnd type="none" w="med" len="med"/>
+                      <a:tailEnd type="none" w="med" len="med"/>
+                    </a:lnR>
+                    <a:lnT w="12700" cap="flat" cmpd="sng" algn="ctr">
+                      <a:solidFill>
+                        <a:srgbClr val="D5DDE8"/>
+                      </a:solidFill>
+                      <a:prstDash val="solid"/>
+                      <a:round/>
+                      <a:headEnd type="none" w="med" len="med"/>
+                      <a:tailEnd type="none" w="med" len="med"/>
+                    </a:lnT>
+                    <a:lnB w="12700" cap="flat" cmpd="sng" algn="ctr">
+                      <a:solidFill>
+                        <a:srgbClr val="D5DDE8"/>
+                      </a:solidFill>
+                      <a:prstDash val="solid"/>
+                      <a:round/>
+                      <a:headEnd type="none" w="med" len="med"/>
+                      <a:tailEnd type="none" w="med" len="med"/>
+                    </a:lnB>
+                  </a:tcPr>
+                </a:tc>
+                <a:tc>
+                  <a:txBody>
+                    <a:bodyPr/>
+                    <a:lstStyle/>
+                    <a:p>
+                      <a:pPr marL="0" indent="0">
+                        <a:buNone/>
+                      </a:pPr>
+                      <a:r>
+                        <a:rPr lang="en-US" sz="1200" dirty="0">
+                          <a:solidFill>
+                            <a:srgbClr val="1F2A44"/>
+                          </a:solidFill>
+                          <a:latin typeface="Calibri" pitchFamily="34" charset="0"/>
+                          <a:ea typeface="Calibri" pitchFamily="34" charset="-122"/>
+                          <a:cs typeface="Calibri" pitchFamily="34" charset="-120"/>
+                        </a:rPr>
+                        <a:t>LockdownContainmentStrategy::executeTactic</a:t>
+                      </a:r>
+                      <a:endParaRPr lang="en-US" sz="1200" dirty="0">
+                        <a:latin typeface="Calibri" charset="0"/>
+                        <a:ea typeface="Calibri" charset="0"/>
+                        <a:cs typeface="Calibri" charset="0"/>
+                      </a:endParaRPr>
+                    </a:p>
+                  </a:txBody>
+                  <a:tcPr marL="73152" marR="73152" marT="73152" marB="73152" anchor="ctr">
+                    <a:lnL w="12700" cap="flat" cmpd="sng" algn="ctr">
+                      <a:solidFill>
+                        <a:srgbClr val="D5DDE8"/>
+                      </a:solidFill>
+                      <a:prstDash val="solid"/>
+                      <a:round/>
+                      <a:headEnd type="none" w="med" len="med"/>
+                      <a:tailEnd type="none" w="med" len="med"/>
+                    </a:lnL>
+                    <a:lnR w="12700" cap="flat" cmpd="sng" algn="ctr">
+                      <a:solidFill>
+                        <a:srgbClr val="D5DDE8"/>
+                      </a:solidFill>
+                      <a:prstDash val="solid"/>
+                      <a:round/>
+                      <a:headEnd type="none" w="med" len="med"/>
+                      <a:tailEnd type="none" w="med" len="med"/>
+                    </a:lnR>
+                    <a:lnT w="12700" cap="flat" cmpd="sng" algn="ctr">
+                      <a:solidFill>
+                        <a:srgbClr val="D5DDE8"/>
+                      </a:solidFill>
+                      <a:prstDash val="solid"/>
+                      <a:round/>
+                      <a:headEnd type="none" w="med" len="med"/>
+                      <a:tailEnd type="none" w="med" len="med"/>
+                    </a:lnT>
+                    <a:lnB w="12700" cap="flat" cmpd="sng" algn="ctr">
+                      <a:solidFill>
+                        <a:srgbClr val="D5DDE8"/>
+                      </a:solidFill>
+                      <a:prstDash val="solid"/>
+                      <a:round/>
+                      <a:headEnd type="none" w="med" len="med"/>
+                      <a:tailEnd type="none" w="med" len="med"/>
+                    </a:lnB>
+                  </a:tcPr>
+                </a:tc>
+                <a:extLst>
+                  <a:ext uri="{0D108BD9-81ED-4DB2-BD59-A6C34878D82A}">
+                    <a16:rowId xmlns:a16="http://schemas.microsoft.com/office/drawing/2014/main" val="10005"/>
+                  </a:ext>
+                </a:extLst>
+              </a:tr>
+              <a:tr h="0">
+                <a:tc>
+                  <a:txBody>
+                    <a:bodyPr/>
+                    <a:lstStyle/>
+                    <a:p>
+                      <a:pPr marL="0" indent="0">
+                        <a:buNone/>
+                      </a:pPr>
+                      <a:r>
+                        <a:rPr lang="en-US" sz="1200" b="1" dirty="0">
+                          <a:solidFill>
+                            <a:srgbClr val="1F2A44"/>
+                          </a:solidFill>
+                          <a:latin typeface="Calibri" pitchFamily="34" charset="0"/>
+                          <a:ea typeface="Calibri" pitchFamily="34" charset="-122"/>
+                          <a:cs typeface="Calibri" pitchFamily="34" charset="-120"/>
+                        </a:rPr>
+                        <a:t>The zone gets locked through the adapter</a:t>
+                      </a:r>
+                      <a:endParaRPr lang="en-US" sz="1200" dirty="0">
+                        <a:latin typeface="Calibri" charset="0"/>
+                        <a:ea typeface="Calibri" charset="0"/>
+                        <a:cs typeface="Calibri" charset="0"/>
+                      </a:endParaRPr>
+                    </a:p>
+                  </a:txBody>
+                  <a:tcPr marL="73152" marR="73152" marT="73152" marB="73152" anchor="ctr">
+                    <a:lnL w="12700" cap="flat" cmpd="sng" algn="ctr">
+                      <a:solidFill>
+                        <a:srgbClr val="D5DDE8"/>
+                      </a:solidFill>
+                      <a:prstDash val="solid"/>
+                      <a:round/>
+                      <a:headEnd type="none" w="med" len="med"/>
+                      <a:tailEnd type="none" w="med" len="med"/>
+                    </a:lnL>
+                    <a:lnR w="12700" cap="flat" cmpd="sng" algn="ctr">
+                      <a:solidFill>
+                        <a:srgbClr val="D5DDE8"/>
+                      </a:solidFill>
+                      <a:prstDash val="solid"/>
+                      <a:round/>
+                      <a:headEnd type="none" w="med" len="med"/>
+                      <a:tailEnd type="none" w="med" len="med"/>
+                    </a:lnR>
+                    <a:lnT w="12700" cap="flat" cmpd="sng" algn="ctr">
+                      <a:solidFill>
+                        <a:srgbClr val="D5DDE8"/>
+                      </a:solidFill>
+                      <a:prstDash val="solid"/>
+                      <a:round/>
+                      <a:headEnd type="none" w="med" len="med"/>
+                      <a:tailEnd type="none" w="med" len="med"/>
+                    </a:lnT>
+                    <a:lnB w="12700" cap="flat" cmpd="sng" algn="ctr">
+                      <a:solidFill>
+                        <a:srgbClr val="D5DDE8"/>
+                      </a:solidFill>
+                      <a:prstDash val="solid"/>
+                      <a:round/>
+                      <a:headEnd type="none" w="med" len="med"/>
+                      <a:tailEnd type="none" w="med" len="med"/>
+                    </a:lnB>
+                  </a:tcPr>
+                </a:tc>
+                <a:tc>
+                  <a:txBody>
+                    <a:bodyPr/>
+                    <a:lstStyle/>
+                    <a:p>
+                      <a:pPr marL="0" indent="0">
+                        <a:buNone/>
+                      </a:pPr>
+                      <a:r>
+                        <a:rPr lang="en-US" sz="1200" dirty="0">
+                          <a:solidFill>
+                            <a:srgbClr val="1F2A44"/>
+                          </a:solidFill>
+                          <a:latin typeface="Calibri" pitchFamily="34" charset="0"/>
+                          <a:ea typeface="Calibri" pitchFamily="34" charset="-122"/>
+                          <a:cs typeface="Calibri" pitchFamily="34" charset="-120"/>
+                        </a:rPr>
+                        <a:t>TurnstileAdapter::lockZone</a:t>
+                      </a:r>
+                      <a:endParaRPr lang="en-US" sz="1200" dirty="0">
+                        <a:latin typeface="Calibri" charset="0"/>
+                        <a:ea typeface="Calibri" charset="0"/>
+                        <a:cs typeface="Calibri" charset="0"/>
+                      </a:endParaRPr>
+                    </a:p>
+                  </a:txBody>
+                  <a:tcPr marL="73152" marR="73152" marT="73152" marB="73152" anchor="ctr">
+                    <a:lnL w="12700" cap="flat" cmpd="sng" algn="ctr">
+                      <a:solidFill>
+                        <a:srgbClr val="D5DDE8"/>
+                      </a:solidFill>
+                      <a:prstDash val="solid"/>
+                      <a:round/>
+                      <a:headEnd type="none" w="med" len="med"/>
+                      <a:tailEnd type="none" w="med" len="med"/>
+                    </a:lnL>
+                    <a:lnR w="12700" cap="flat" cmpd="sng" algn="ctr">
+                      <a:solidFill>
+                        <a:srgbClr val="D5DDE8"/>
+                      </a:solidFill>
+                      <a:prstDash val="solid"/>
+                      <a:round/>
+                      <a:headEnd type="none" w="med" len="med"/>
+                      <a:tailEnd type="none" w="med" len="med"/>
+                    </a:lnR>
+                    <a:lnT w="12700" cap="flat" cmpd="sng" algn="ctr">
+                      <a:solidFill>
+                        <a:srgbClr val="D5DDE8"/>
+                      </a:solidFill>
+                      <a:prstDash val="solid"/>
+                      <a:round/>
+                      <a:headEnd type="none" w="med" len="med"/>
+                      <a:tailEnd type="none" w="med" len="med"/>
+                    </a:lnT>
+                    <a:lnB w="12700" cap="flat" cmpd="sng" algn="ctr">
+                      <a:solidFill>
+                        <a:srgbClr val="D5DDE8"/>
+                      </a:solidFill>
+                      <a:prstDash val="solid"/>
+                      <a:round/>
+                      <a:headEnd type="none" w="med" len="med"/>
+                      <a:tailEnd type="none" w="med" len="med"/>
+                    </a:lnB>
+                  </a:tcPr>
+                </a:tc>
+                <a:extLst>
+                  <a:ext uri="{0D108BD9-81ED-4DB2-BD59-A6C34878D82A}">
+                    <a16:rowId xmlns:a16="http://schemas.microsoft.com/office/drawing/2014/main" val="10006"/>
+                  </a:ext>
+                </a:extLst>
+              </a:tr>
+              <a:tr h="0">
+                <a:tc>
+                  <a:txBody>
+                    <a:bodyPr/>
+                    <a:lstStyle/>
+                    <a:p>
+                      <a:pPr marL="0" indent="0">
+                        <a:buNone/>
+                      </a:pPr>
+                      <a:r>
+                        <a:rPr lang="en-US" sz="1200" b="1" dirty="0">
+                          <a:solidFill>
+                            <a:srgbClr val="1F2A44"/>
+                          </a:solidFill>
+                          <a:latin typeface="Calibri" pitchFamily="34" charset="0"/>
+                          <a:ea typeface="Calibri" pitchFamily="34" charset="-122"/>
+                          <a:cs typeface="Calibri" pitchFamily="34" charset="-120"/>
+                        </a:rPr>
+                        <a:t>Every team is notified</a:t>
+                      </a:r>
+                      <a:endParaRPr lang="en-US" sz="1200" dirty="0">
+                        <a:latin typeface="Calibri" charset="0"/>
+                        <a:ea typeface="Calibri" charset="0"/>
+                        <a:cs typeface="Calibri" charset="0"/>
+                      </a:endParaRPr>
+                    </a:p>
+                  </a:txBody>
+                  <a:tcPr marL="73152" marR="73152" marT="73152" marB="73152" anchor="ctr">
+                    <a:lnL w="12700" cap="flat" cmpd="sng" algn="ctr">
+                      <a:solidFill>
+                        <a:srgbClr val="D5DDE8"/>
+                      </a:solidFill>
+                      <a:prstDash val="solid"/>
+                      <a:round/>
+                      <a:headEnd type="none" w="med" len="med"/>
+                      <a:tailEnd type="none" w="med" len="med"/>
+                    </a:lnL>
+                    <a:lnR w="12700" cap="flat" cmpd="sng" algn="ctr">
+                      <a:solidFill>
+                        <a:srgbClr val="D5DDE8"/>
+                      </a:solidFill>
+                      <a:prstDash val="solid"/>
+                      <a:round/>
+                      <a:headEnd type="none" w="med" len="med"/>
+                      <a:tailEnd type="none" w="med" len="med"/>
+                    </a:lnR>
+                    <a:lnT w="12700" cap="flat" cmpd="sng" algn="ctr">
+                      <a:solidFill>
+                        <a:srgbClr val="D5DDE8"/>
+                      </a:solidFill>
+                      <a:prstDash val="solid"/>
+                      <a:round/>
+                      <a:headEnd type="none" w="med" len="med"/>
+                      <a:tailEnd type="none" w="med" len="med"/>
+                    </a:lnT>
+                    <a:lnB w="12700" cap="flat" cmpd="sng" algn="ctr">
+                      <a:solidFill>
+                        <a:srgbClr val="D5DDE8"/>
+                      </a:solidFill>
+                      <a:prstDash val="solid"/>
+                      <a:round/>
+                      <a:headEnd type="none" w="med" len="med"/>
+                      <a:tailEnd type="none" w="med" len="med"/>
+                    </a:lnB>
+                  </a:tcPr>
+                </a:tc>
+                <a:tc>
+                  <a:txBody>
+                    <a:bodyPr/>
+                    <a:lstStyle/>
+                    <a:p>
+                      <a:pPr marL="0" indent="0">
+                        <a:buNone/>
+                      </a:pPr>
+                      <a:r>
+                        <a:rPr lang="en-US" sz="1200" dirty="0">
+                          <a:solidFill>
+                            <a:srgbClr val="1F2A44"/>
+                          </a:solidFill>
+                          <a:latin typeface="Calibri" pitchFamily="34" charset="0"/>
+                          <a:ea typeface="Calibri" pitchFamily="34" charset="-122"/>
+                          <a:cs typeface="Calibri" pitchFamily="34" charset="-120"/>
+                        </a:rPr>
+                        <a:t>CentralDispatchMediator::notify</a:t>
+                      </a:r>
+                      <a:endParaRPr lang="en-US" sz="1200" dirty="0">
+                        <a:latin typeface="Calibri" charset="0"/>
+                        <a:ea typeface="Calibri" charset="0"/>
+                        <a:cs typeface="Calibri" charset="0"/>
+                      </a:endParaRPr>
+                    </a:p>
+                  </a:txBody>
+                  <a:tcPr marL="73152" marR="73152" marT="73152" marB="73152" anchor="ctr">
+                    <a:lnL w="12700" cap="flat" cmpd="sng" algn="ctr">
+                      <a:solidFill>
+                        <a:srgbClr val="D5DDE8"/>
+                      </a:solidFill>
+                      <a:prstDash val="solid"/>
+                      <a:round/>
+                      <a:headEnd type="none" w="med" len="med"/>
+                      <a:tailEnd type="none" w="med" len="med"/>
+                    </a:lnL>
+                    <a:lnR w="12700" cap="flat" cmpd="sng" algn="ctr">
+                      <a:solidFill>
+                        <a:srgbClr val="D5DDE8"/>
+                      </a:solidFill>
+                      <a:prstDash val="solid"/>
+                      <a:round/>
+                      <a:headEnd type="none" w="med" len="med"/>
+                      <a:tailEnd type="none" w="med" len="med"/>
+                    </a:lnR>
+                    <a:lnT w="12700" cap="flat" cmpd="sng" algn="ctr">
+                      <a:solidFill>
+                        <a:srgbClr val="D5DDE8"/>
+                      </a:solidFill>
+                      <a:prstDash val="solid"/>
+                      <a:round/>
+                      <a:headEnd type="none" w="med" len="med"/>
+                      <a:tailEnd type="none" w="med" len="med"/>
+                    </a:lnT>
+                    <a:lnB w="12700" cap="flat" cmpd="sng" algn="ctr">
+                      <a:solidFill>
+                        <a:srgbClr val="D5DDE8"/>
+                      </a:solidFill>
+                      <a:prstDash val="solid"/>
+                      <a:round/>
+                      <a:headEnd type="none" w="med" len="med"/>
+                      <a:tailEnd type="none" w="med" len="med"/>
+                    </a:lnB>
+                  </a:tcPr>
+                </a:tc>
+                <a:extLst>
+                  <a:ext uri="{0D108BD9-81ED-4DB2-BD59-A6C34878D82A}">
+                    <a16:rowId xmlns:a16="http://schemas.microsoft.com/office/drawing/2014/main" val="10007"/>
+                  </a:ext>
+                </a:extLst>
+              </a:tr>
+            </a:tbl>
+          </a:graphicData>
+        </a:graphic>
+      </p:graphicFrame>
+    </p:spTree>
+  </p:cSld>
+  <p:clrMapOvr>
+    <a:masterClrMapping/>
+  </p:clrMapOvr>
+</p:sld>
+</file>
+
+<file path=ppt/slides/slide11.xml><?xml version="1.0" encoding="utf-8"?>
+<p:sld xmlns:a="http://schemas.openxmlformats.org/drawingml/2006/main" xmlns:r="http://schemas.openxmlformats.org/officeDocument/2006/relationships" xmlns:p="http://schemas.openxmlformats.org/presentationml/2006/main">
   <p:cSld name="Slide 10">
     <p:bg>
       <p:bgPr>
@@ -2193,7 +3521,7 @@
 </p:sld>
 </file>
 
-<file path=ppt/slides/slide11.xml><?xml version="1.0" encoding="utf-8"?>
+<file path=ppt/slides/slide12.xml><?xml version="1.0" encoding="utf-8"?>
 <p:sld xmlns:a="http://schemas.openxmlformats.org/drawingml/2006/main" xmlns:r="http://schemas.openxmlformats.org/officeDocument/2006/relationships" xmlns:p="http://schemas.openxmlformats.org/presentationml/2006/main">
   <p:cSld name="Slide 11">
     <p:bg>
@@ -5796,6 +7124,419 @@
 
 <file path=ppt/slides/slide8.xml><?xml version="1.0" encoding="utf-8"?>
 <p:sld xmlns:a="http://schemas.openxmlformats.org/drawingml/2006/main" xmlns:r="http://schemas.openxmlformats.org/officeDocument/2006/relationships" xmlns:p="http://schemas.openxmlformats.org/presentationml/2006/main">
+  <p:cSld>
+    <p:bg>
+      <p:bgPr>
+        <a:solidFill>
+          <a:srgbClr val="FFFFFF"/>
+        </a:solidFill>
+        <a:effectLst/>
+      </p:bgPr>
+    </p:bg>
+    <p:spTree>
+      <p:nvGrpSpPr>
+        <p:cNvPr id="1" name="">
+          <a:extLst>
+            <a:ext uri="{FF2B5EF4-FFF2-40B4-BE49-F238E27FC236}">
+              <a16:creationId xmlns:a16="http://schemas.microsoft.com/office/drawing/2014/main" id="{AB0FC006-79B7-AFCB-3695-DCC94D17BF80}"/>
+            </a:ext>
+          </a:extLst>
+        </p:cNvPr>
+        <p:cNvGrpSpPr/>
+        <p:nvPr/>
+      </p:nvGrpSpPr>
+      <p:grpSpPr>
+        <a:xfrm>
+          <a:off x="0" y="0"/>
+          <a:ext cx="0" cy="0"/>
+          <a:chOff x="0" y="0"/>
+          <a:chExt cx="0" cy="0"/>
+        </a:xfrm>
+      </p:grpSpPr>
+      <p:sp>
+        <p:nvSpPr>
+          <p:cNvPr id="2" name="Text 0">
+            <a:extLst>
+              <a:ext uri="{FF2B5EF4-FFF2-40B4-BE49-F238E27FC236}">
+                <a16:creationId xmlns:a16="http://schemas.microsoft.com/office/drawing/2014/main" id="{F5BDBF9D-BB5B-DDDF-00BA-9D861BF18ADE}"/>
+              </a:ext>
+            </a:extLst>
+          </p:cNvPr>
+          <p:cNvSpPr txBox="1"/>
+          <p:nvPr/>
+        </p:nvSpPr>
+        <p:spPr>
+          <a:xfrm>
+            <a:off x="457200" y="274320"/>
+            <a:ext cx="8229600" cy="548640"/>
+          </a:xfrm>
+          <a:prstGeom prst="rect">
+            <a:avLst/>
+          </a:prstGeom>
+          <a:noFill/>
+          <a:ln/>
+        </p:spPr>
+        <p:txBody>
+          <a:bodyPr wrap="square" lIns="0" tIns="0" rIns="0" bIns="0" rtlCol="0" anchor="ctr"/>
+          <a:lstStyle/>
+          <a:p>
+            <a:pPr marL="0" indent="0">
+              <a:buNone/>
+            </a:pPr>
+            <a:r>
+              <a:rPr lang="en-US" sz="2500" b="1" dirty="0">
+                <a:solidFill>
+                  <a:srgbClr val="1F2A44"/>
+                </a:solidFill>
+                <a:latin typeface="Calibri" pitchFamily="34" charset="0"/>
+                <a:ea typeface="Calibri" pitchFamily="34" charset="-122"/>
+                <a:cs typeface="Calibri" pitchFamily="34" charset="-120"/>
+              </a:rPr>
+              <a:t>7.5. Why we chose State over a simpler approach</a:t>
+            </a:r>
+            <a:endParaRPr lang="en-US" sz="2500" dirty="0"/>
+          </a:p>
+        </p:txBody>
+      </p:sp>
+      <p:sp>
+        <p:nvSpPr>
+          <p:cNvPr id="4" name="Text 1">
+            <a:extLst>
+              <a:ext uri="{FF2B5EF4-FFF2-40B4-BE49-F238E27FC236}">
+                <a16:creationId xmlns:a16="http://schemas.microsoft.com/office/drawing/2014/main" id="{356CA757-5624-7308-8302-38A2F935336E}"/>
+              </a:ext>
+            </a:extLst>
+          </p:cNvPr>
+          <p:cNvSpPr txBox="1"/>
+          <p:nvPr/>
+        </p:nvSpPr>
+        <p:spPr>
+          <a:xfrm>
+            <a:off x="457200" y="1051560"/>
+            <a:ext cx="8229600" cy="3520440"/>
+          </a:xfrm>
+          <a:prstGeom prst="rect">
+            <a:avLst/>
+          </a:prstGeom>
+          <a:noFill/>
+          <a:ln/>
+        </p:spPr>
+        <p:txBody>
+          <a:bodyPr wrap="square" lIns="0" tIns="0" rIns="0" bIns="0" rtlCol="0" anchor="t"/>
+          <a:lstStyle/>
+          <a:p>
+            <a:pPr marL="342900" indent="-342900">
+              <a:lnSpc>
+                <a:spcPct val="105000"/>
+              </a:lnSpc>
+              <a:spcAft>
+                <a:spcPts val="800"/>
+              </a:spcAft>
+              <a:buSzPct val="100000"/>
+              <a:buChar char="•"/>
+            </a:pPr>
+            <a:r>
+              <a:rPr lang="en-GB" sz="1400" dirty="0">
+                <a:solidFill>
+                  <a:srgbClr val="1F2A44"/>
+                </a:solidFill>
+                <a:latin typeface="Calibri" pitchFamily="34" charset="0"/>
+                <a:ea typeface="Calibri" pitchFamily="34" charset="-122"/>
+                <a:cs typeface="Calibri" pitchFamily="34" charset="-120"/>
+              </a:rPr>
+              <a:t>An incident has to go through its life in a strict order: Reported → Dispatched → Contained → Resolved. </a:t>
+            </a:r>
+          </a:p>
+          <a:p>
+            <a:pPr marL="342900" indent="-342900">
+              <a:lnSpc>
+                <a:spcPct val="105000"/>
+              </a:lnSpc>
+              <a:spcAft>
+                <a:spcPts val="800"/>
+              </a:spcAft>
+              <a:buSzPct val="100000"/>
+              <a:buChar char="•"/>
+            </a:pPr>
+            <a:r>
+              <a:rPr lang="en-GB" sz="1400" dirty="0">
+                <a:solidFill>
+                  <a:srgbClr val="1F2A44"/>
+                </a:solidFill>
+                <a:latin typeface="Calibri" pitchFamily="34" charset="0"/>
+                <a:ea typeface="Calibri" pitchFamily="34" charset="-122"/>
+                <a:cs typeface="Calibri" pitchFamily="34" charset="-120"/>
+              </a:rPr>
+              <a:t>Skipping steps has to be blocked and State is how we enforce that cleanly.</a:t>
+            </a:r>
+          </a:p>
+          <a:p>
+            <a:pPr marL="342900" indent="-342900">
+              <a:lnSpc>
+                <a:spcPct val="105000"/>
+              </a:lnSpc>
+              <a:spcAft>
+                <a:spcPts val="800"/>
+              </a:spcAft>
+              <a:buSzPct val="100000"/>
+              <a:buChar char="•"/>
+            </a:pPr>
+            <a:r>
+              <a:rPr lang="en-GB" sz="1400" dirty="0">
+                <a:solidFill>
+                  <a:srgbClr val="1F2A44"/>
+                </a:solidFill>
+                <a:latin typeface="Calibri" pitchFamily="34" charset="0"/>
+                <a:ea typeface="Calibri" pitchFamily="34" charset="-122"/>
+                <a:cs typeface="Calibri" pitchFamily="34" charset="-120"/>
+              </a:rPr>
+              <a:t>Otherwise, Incident would need a bunch of </a:t>
+            </a:r>
+            <a:r>
+              <a:rPr lang="en-GB" sz="1400" dirty="0" err="1">
+                <a:solidFill>
+                  <a:srgbClr val="1F2A44"/>
+                </a:solidFill>
+                <a:latin typeface="Calibri" pitchFamily="34" charset="0"/>
+                <a:ea typeface="Calibri" pitchFamily="34" charset="-122"/>
+                <a:cs typeface="Calibri" pitchFamily="34" charset="-120"/>
+              </a:rPr>
+              <a:t>boolean</a:t>
+            </a:r>
+            <a:r>
+              <a:rPr lang="en-GB" sz="1400" dirty="0">
+                <a:solidFill>
+                  <a:srgbClr val="1F2A44"/>
+                </a:solidFill>
+                <a:latin typeface="Calibri" pitchFamily="34" charset="0"/>
+                <a:ea typeface="Calibri" pitchFamily="34" charset="-122"/>
+                <a:cs typeface="Calibri" pitchFamily="34" charset="-120"/>
+              </a:rPr>
+              <a:t> flags like </a:t>
+            </a:r>
+            <a:r>
+              <a:rPr lang="en-GB" sz="1400" dirty="0" err="1">
+                <a:solidFill>
+                  <a:srgbClr val="1F2A44"/>
+                </a:solidFill>
+                <a:latin typeface="Calibri" pitchFamily="34" charset="0"/>
+                <a:ea typeface="Calibri" pitchFamily="34" charset="-122"/>
+                <a:cs typeface="Calibri" pitchFamily="34" charset="-120"/>
+              </a:rPr>
+              <a:t>isDispatched</a:t>
+            </a:r>
+            <a:r>
+              <a:rPr lang="en-GB" sz="1400" dirty="0">
+                <a:solidFill>
+                  <a:srgbClr val="1F2A44"/>
+                </a:solidFill>
+                <a:latin typeface="Calibri" pitchFamily="34" charset="0"/>
+                <a:ea typeface="Calibri" pitchFamily="34" charset="-122"/>
+                <a:cs typeface="Calibri" pitchFamily="34" charset="-120"/>
+              </a:rPr>
+              <a:t>, </a:t>
+            </a:r>
+            <a:r>
+              <a:rPr lang="en-GB" sz="1400" dirty="0" err="1">
+                <a:solidFill>
+                  <a:srgbClr val="1F2A44"/>
+                </a:solidFill>
+                <a:latin typeface="Calibri" pitchFamily="34" charset="0"/>
+                <a:ea typeface="Calibri" pitchFamily="34" charset="-122"/>
+                <a:cs typeface="Calibri" pitchFamily="34" charset="-120"/>
+              </a:rPr>
+              <a:t>isContained</a:t>
+            </a:r>
+            <a:r>
+              <a:rPr lang="en-GB" sz="1400" dirty="0">
+                <a:solidFill>
+                  <a:srgbClr val="1F2A44"/>
+                </a:solidFill>
+                <a:latin typeface="Calibri" pitchFamily="34" charset="0"/>
+                <a:ea typeface="Calibri" pitchFamily="34" charset="-122"/>
+                <a:cs typeface="Calibri" pitchFamily="34" charset="-120"/>
+              </a:rPr>
+              <a:t>, </a:t>
+            </a:r>
+            <a:r>
+              <a:rPr lang="en-GB" sz="1400" dirty="0" err="1">
+                <a:solidFill>
+                  <a:srgbClr val="1F2A44"/>
+                </a:solidFill>
+                <a:latin typeface="Calibri" pitchFamily="34" charset="0"/>
+                <a:ea typeface="Calibri" pitchFamily="34" charset="-122"/>
+                <a:cs typeface="Calibri" pitchFamily="34" charset="-120"/>
+              </a:rPr>
+              <a:t>isResolved</a:t>
+            </a:r>
+            <a:r>
+              <a:rPr lang="en-GB" sz="1400" dirty="0">
+                <a:solidFill>
+                  <a:srgbClr val="1F2A44"/>
+                </a:solidFill>
+                <a:latin typeface="Calibri" pitchFamily="34" charset="0"/>
+                <a:ea typeface="Calibri" pitchFamily="34" charset="-122"/>
+                <a:cs typeface="Calibri" pitchFamily="34" charset="-120"/>
+              </a:rPr>
+              <a:t>, and every single method would need its own if/else chain checking those flags before deciding what's allowed.</a:t>
+            </a:r>
+            <a:r>
+              <a:rPr lang="en-US" sz="1400" dirty="0">
+                <a:solidFill>
+                  <a:srgbClr val="1F2A44"/>
+                </a:solidFill>
+                <a:latin typeface="Calibri" pitchFamily="34" charset="0"/>
+                <a:ea typeface="Calibri" pitchFamily="34" charset="-122"/>
+                <a:cs typeface="Calibri" pitchFamily="34" charset="-120"/>
+              </a:rPr>
+              <a:t> </a:t>
+            </a:r>
+          </a:p>
+          <a:p>
+            <a:pPr marL="342900" indent="-342900">
+              <a:lnSpc>
+                <a:spcPct val="105000"/>
+              </a:lnSpc>
+              <a:spcAft>
+                <a:spcPts val="800"/>
+              </a:spcAft>
+              <a:buSzPct val="100000"/>
+              <a:buChar char="•"/>
+            </a:pPr>
+            <a:r>
+              <a:rPr lang="en-GB" sz="1400" dirty="0">
+                <a:solidFill>
+                  <a:srgbClr val="1F2A44"/>
+                </a:solidFill>
+                <a:latin typeface="Calibri" pitchFamily="34" charset="0"/>
+                <a:ea typeface="Calibri" pitchFamily="34" charset="-122"/>
+                <a:cs typeface="Calibri" pitchFamily="34" charset="-120"/>
+              </a:rPr>
+              <a:t>What State gives us instead: each stage is its own class (</a:t>
+            </a:r>
+            <a:r>
+              <a:rPr lang="en-GB" sz="1400" dirty="0" err="1">
+                <a:solidFill>
+                  <a:srgbClr val="1F2A44"/>
+                </a:solidFill>
+                <a:latin typeface="Calibri" pitchFamily="34" charset="0"/>
+                <a:ea typeface="Calibri" pitchFamily="34" charset="-122"/>
+                <a:cs typeface="Calibri" pitchFamily="34" charset="-120"/>
+              </a:rPr>
+              <a:t>ReportedState</a:t>
+            </a:r>
+            <a:r>
+              <a:rPr lang="en-GB" sz="1400" dirty="0">
+                <a:solidFill>
+                  <a:srgbClr val="1F2A44"/>
+                </a:solidFill>
+                <a:latin typeface="Calibri" pitchFamily="34" charset="0"/>
+                <a:ea typeface="Calibri" pitchFamily="34" charset="-122"/>
+                <a:cs typeface="Calibri" pitchFamily="34" charset="-120"/>
+              </a:rPr>
+              <a:t>, </a:t>
+            </a:r>
+            <a:r>
+              <a:rPr lang="en-GB" sz="1400" dirty="0" err="1">
+                <a:solidFill>
+                  <a:srgbClr val="1F2A44"/>
+                </a:solidFill>
+                <a:latin typeface="Calibri" pitchFamily="34" charset="0"/>
+                <a:ea typeface="Calibri" pitchFamily="34" charset="-122"/>
+                <a:cs typeface="Calibri" pitchFamily="34" charset="-120"/>
+              </a:rPr>
+              <a:t>DispatchedState</a:t>
+            </a:r>
+            <a:r>
+              <a:rPr lang="en-GB" sz="1400" dirty="0">
+                <a:solidFill>
+                  <a:srgbClr val="1F2A44"/>
+                </a:solidFill>
+                <a:latin typeface="Calibri" pitchFamily="34" charset="0"/>
+                <a:ea typeface="Calibri" pitchFamily="34" charset="-122"/>
+                <a:cs typeface="Calibri" pitchFamily="34" charset="-120"/>
+              </a:rPr>
+              <a:t>, </a:t>
+            </a:r>
+            <a:r>
+              <a:rPr lang="en-GB" sz="1400" dirty="0" err="1">
+                <a:solidFill>
+                  <a:srgbClr val="1F2A44"/>
+                </a:solidFill>
+                <a:latin typeface="Calibri" pitchFamily="34" charset="0"/>
+                <a:ea typeface="Calibri" pitchFamily="34" charset="-122"/>
+                <a:cs typeface="Calibri" pitchFamily="34" charset="-120"/>
+              </a:rPr>
+              <a:t>ContainedState</a:t>
+            </a:r>
+            <a:r>
+              <a:rPr lang="en-GB" sz="1400" dirty="0">
+                <a:solidFill>
+                  <a:srgbClr val="1F2A44"/>
+                </a:solidFill>
+                <a:latin typeface="Calibri" pitchFamily="34" charset="0"/>
+                <a:ea typeface="Calibri" pitchFamily="34" charset="-122"/>
+                <a:cs typeface="Calibri" pitchFamily="34" charset="-120"/>
+              </a:rPr>
+              <a:t>, </a:t>
+            </a:r>
+            <a:r>
+              <a:rPr lang="en-GB" sz="1400" dirty="0" err="1">
+                <a:solidFill>
+                  <a:srgbClr val="1F2A44"/>
+                </a:solidFill>
+                <a:latin typeface="Calibri" pitchFamily="34" charset="0"/>
+                <a:ea typeface="Calibri" pitchFamily="34" charset="-122"/>
+                <a:cs typeface="Calibri" pitchFamily="34" charset="-120"/>
+              </a:rPr>
+              <a:t>ResolvedState</a:t>
+            </a:r>
+            <a:r>
+              <a:rPr lang="en-GB" sz="1400" dirty="0">
+                <a:solidFill>
+                  <a:srgbClr val="1F2A44"/>
+                </a:solidFill>
+                <a:latin typeface="Calibri" pitchFamily="34" charset="0"/>
+                <a:ea typeface="Calibri" pitchFamily="34" charset="-122"/>
+                <a:cs typeface="Calibri" pitchFamily="34" charset="-120"/>
+              </a:rPr>
+              <a:t>), and each one only implements the moves that are actually legal from that stage.</a:t>
+            </a:r>
+          </a:p>
+          <a:p>
+            <a:pPr marL="342900" indent="-342900">
+              <a:lnSpc>
+                <a:spcPct val="100000"/>
+              </a:lnSpc>
+              <a:spcAft>
+                <a:spcPts val="800"/>
+              </a:spcAft>
+              <a:buSzPct val="100000"/>
+              <a:buChar char="•"/>
+            </a:pPr>
+            <a:r>
+              <a:rPr lang="en-GB" sz="1400" dirty="0"/>
+              <a:t>So instead of one method asking "what state am I in, and is this move OK," the Incident just asks its current state object to handle the request, and that state object already knows what it's allowed to do. The rejection logic lives right next to the stage it belongs to, not scattered across Incident</a:t>
+            </a:r>
+            <a:endParaRPr lang="en-US" sz="1400" dirty="0"/>
+          </a:p>
+        </p:txBody>
+      </p:sp>
+    </p:spTree>
+    <p:extLst>
+      <p:ext uri="{BB962C8B-B14F-4D97-AF65-F5344CB8AC3E}">
+        <p14:creationId xmlns:p14="http://schemas.microsoft.com/office/powerpoint/2010/main" val="3081056156"/>
+      </p:ext>
+    </p:extLst>
+  </p:cSld>
+  <p:clrMapOvr>
+    <a:masterClrMapping/>
+  </p:clrMapOvr>
+</p:sld>
+</file>
+
+<file path=ppt/slides/slide9.xml><?xml version="1.0" encoding="utf-8"?>
+<p:sld xmlns:a="http://schemas.openxmlformats.org/drawingml/2006/main" xmlns:r="http://schemas.openxmlformats.org/officeDocument/2006/relationships" xmlns:p="http://schemas.openxmlformats.org/presentationml/2006/main">
   <p:cSld name="Slide 8">
     <p:bg>
       <p:bgPr>
@@ -6000,1222 +7741,6 @@
           </a:p>
         </p:txBody>
       </p:sp>
-    </p:spTree>
-  </p:cSld>
-  <p:clrMapOvr>
-    <a:masterClrMapping/>
-  </p:clrMapOvr>
-</p:sld>
-</file>
-
-<file path=ppt/slides/slide9.xml><?xml version="1.0" encoding="utf-8"?>
-<p:sld xmlns:a="http://schemas.openxmlformats.org/drawingml/2006/main" xmlns:r="http://schemas.openxmlformats.org/officeDocument/2006/relationships" xmlns:p="http://schemas.openxmlformats.org/presentationml/2006/main">
-  <p:cSld name="Slide 9">
-    <p:bg>
-      <p:bgPr>
-        <a:solidFill>
-          <a:srgbClr val="FFFFFF"/>
-        </a:solidFill>
-        <a:effectLst/>
-      </p:bgPr>
-    </p:bg>
-    <p:spTree>
-      <p:nvGrpSpPr>
-        <p:cNvPr id="1" name=""/>
-        <p:cNvGrpSpPr/>
-        <p:nvPr/>
-      </p:nvGrpSpPr>
-      <p:grpSpPr>
-        <a:xfrm>
-          <a:off x="0" y="0"/>
-          <a:ext cx="0" cy="0"/>
-          <a:chOff x="0" y="0"/>
-          <a:chExt cx="0" cy="0"/>
-        </a:xfrm>
-      </p:grpSpPr>
-      <p:sp>
-        <p:nvSpPr>
-          <p:cNvPr id="2" name="Text 0"/>
-          <p:cNvSpPr txBox="1"/>
-          <p:nvPr/>
-        </p:nvSpPr>
-        <p:spPr>
-          <a:xfrm>
-            <a:off x="457200" y="274320"/>
-            <a:ext cx="8229600" cy="548640"/>
-          </a:xfrm>
-          <a:prstGeom prst="rect">
-            <a:avLst/>
-          </a:prstGeom>
-          <a:noFill/>
-          <a:ln/>
-        </p:spPr>
-        <p:txBody>
-          <a:bodyPr wrap="square" lIns="0" tIns="0" rIns="0" bIns="0" rtlCol="0" anchor="ctr"/>
-          <a:lstStyle/>
-          <a:p>
-            <a:pPr marL="0" indent="0">
-              <a:buNone/>
-            </a:pPr>
-            <a:r>
-              <a:rPr lang="en-US" sz="2500" b="1" dirty="0">
-                <a:solidFill>
-                  <a:srgbClr val="1F2A44"/>
-                </a:solidFill>
-                <a:latin typeface="Calibri" pitchFamily="34" charset="0"/>
-                <a:ea typeface="Calibri" pitchFamily="34" charset="-122"/>
-                <a:cs typeface="Calibri" pitchFamily="34" charset="-120"/>
-              </a:rPr>
-              <a:t>9. Matching our diagrams to our actual code</a:t>
-            </a:r>
-            <a:endParaRPr lang="en-US" sz="2500" dirty="0"/>
-          </a:p>
-        </p:txBody>
-      </p:sp>
-      <p:graphicFrame>
-        <p:nvGraphicFramePr>
-          <p:cNvPr id="10" name="Table 0"/>
-          <p:cNvGraphicFramePr>
-            <a:graphicFrameLocks noGrp="1"/>
-          </p:cNvGraphicFramePr>
-          <p:nvPr>
-            <p:extLst>
-              <p:ext uri="{D42A27DB-BD31-4B8C-83A1-F6EECF244321}">
-                <p14:modId xmlns:p14="http://schemas.microsoft.com/office/powerpoint/2010/main" val="1579011935"/>
-              </p:ext>
-            </p:extLst>
-          </p:nvPr>
-        </p:nvGraphicFramePr>
-        <p:xfrm>
-          <a:off x="457200" y="1005840"/>
-          <a:ext cx="8229600" cy="2816352"/>
-        </p:xfrm>
-        <a:graphic>
-          <a:graphicData uri="http://schemas.openxmlformats.org/drawingml/2006/table">
-            <a:tbl>
-              <a:tblPr/>
-              <a:tblGrid>
-                <a:gridCol w="4572000">
-                  <a:extLst>
-                    <a:ext uri="{9D8B030D-6E8A-4147-A177-3AD203B41FA5}">
-                      <a16:colId xmlns:a16="http://schemas.microsoft.com/office/drawing/2014/main" val="20000"/>
-                    </a:ext>
-                  </a:extLst>
-                </a:gridCol>
-                <a:gridCol w="3657600">
-                  <a:extLst>
-                    <a:ext uri="{9D8B030D-6E8A-4147-A177-3AD203B41FA5}">
-                      <a16:colId xmlns:a16="http://schemas.microsoft.com/office/drawing/2014/main" val="20001"/>
-                    </a:ext>
-                  </a:extLst>
-                </a:gridCol>
-              </a:tblGrid>
-              <a:tr h="0">
-                <a:tc>
-                  <a:txBody>
-                    <a:bodyPr/>
-                    <a:lstStyle/>
-                    <a:p>
-                      <a:pPr marL="0" indent="0">
-                        <a:buNone/>
-                      </a:pPr>
-                      <a:r>
-                        <a:rPr lang="en-US" sz="1200" b="1" dirty="0">
-                          <a:solidFill>
-                            <a:srgbClr val="FFFFFF"/>
-                          </a:solidFill>
-                          <a:latin typeface="Calibri" pitchFamily="34" charset="0"/>
-                          <a:ea typeface="Calibri" pitchFamily="34" charset="-122"/>
-                          <a:cs typeface="Calibri" pitchFamily="34" charset="-120"/>
-                        </a:rPr>
-                        <a:t>Arrow on the sequence diagram</a:t>
-                      </a:r>
-                      <a:endParaRPr lang="en-US" sz="1200" dirty="0">
-                        <a:latin typeface="Calibri" charset="0"/>
-                        <a:ea typeface="Calibri" charset="0"/>
-                        <a:cs typeface="Calibri" charset="0"/>
-                      </a:endParaRPr>
-                    </a:p>
-                  </a:txBody>
-                  <a:tcPr marL="73152" marR="73152" marT="73152" marB="73152" anchor="ctr">
-                    <a:lnL w="12700" cap="flat" cmpd="sng" algn="ctr">
-                      <a:solidFill>
-                        <a:srgbClr val="D5DDE8"/>
-                      </a:solidFill>
-                      <a:prstDash val="solid"/>
-                      <a:round/>
-                      <a:headEnd type="none" w="med" len="med"/>
-                      <a:tailEnd type="none" w="med" len="med"/>
-                    </a:lnL>
-                    <a:lnR w="12700" cap="flat" cmpd="sng" algn="ctr">
-                      <a:solidFill>
-                        <a:srgbClr val="D5DDE8"/>
-                      </a:solidFill>
-                      <a:prstDash val="solid"/>
-                      <a:round/>
-                      <a:headEnd type="none" w="med" len="med"/>
-                      <a:tailEnd type="none" w="med" len="med"/>
-                    </a:lnR>
-                    <a:lnT w="12700" cap="flat" cmpd="sng" algn="ctr">
-                      <a:solidFill>
-                        <a:srgbClr val="D5DDE8"/>
-                      </a:solidFill>
-                      <a:prstDash val="solid"/>
-                      <a:round/>
-                      <a:headEnd type="none" w="med" len="med"/>
-                      <a:tailEnd type="none" w="med" len="med"/>
-                    </a:lnT>
-                    <a:lnB w="12700" cap="flat" cmpd="sng" algn="ctr">
-                      <a:solidFill>
-                        <a:srgbClr val="D5DDE8"/>
-                      </a:solidFill>
-                      <a:prstDash val="solid"/>
-                      <a:round/>
-                      <a:headEnd type="none" w="med" len="med"/>
-                      <a:tailEnd type="none" w="med" len="med"/>
-                    </a:lnB>
-                    <a:solidFill>
-                      <a:srgbClr val="1F2A44"/>
-                    </a:solidFill>
-                  </a:tcPr>
-                </a:tc>
-                <a:tc>
-                  <a:txBody>
-                    <a:bodyPr/>
-                    <a:lstStyle/>
-                    <a:p>
-                      <a:pPr marL="0" indent="0">
-                        <a:buNone/>
-                      </a:pPr>
-                      <a:r>
-                        <a:rPr lang="en-US" sz="1200" b="1" dirty="0">
-                          <a:solidFill>
-                            <a:srgbClr val="FFFFFF"/>
-                          </a:solidFill>
-                          <a:latin typeface="Calibri" pitchFamily="34" charset="0"/>
-                          <a:ea typeface="Calibri" pitchFamily="34" charset="-122"/>
-                          <a:cs typeface="Calibri" pitchFamily="34" charset="-120"/>
-                        </a:rPr>
-                        <a:t>Where it actually happens in our code</a:t>
-                      </a:r>
-                      <a:endParaRPr lang="en-US" sz="1200" dirty="0">
-                        <a:latin typeface="Calibri" charset="0"/>
-                        <a:ea typeface="Calibri" charset="0"/>
-                        <a:cs typeface="Calibri" charset="0"/>
-                      </a:endParaRPr>
-                    </a:p>
-                  </a:txBody>
-                  <a:tcPr marL="73152" marR="73152" marT="73152" marB="73152" anchor="ctr">
-                    <a:lnL w="12700" cap="flat" cmpd="sng" algn="ctr">
-                      <a:solidFill>
-                        <a:srgbClr val="D5DDE8"/>
-                      </a:solidFill>
-                      <a:prstDash val="solid"/>
-                      <a:round/>
-                      <a:headEnd type="none" w="med" len="med"/>
-                      <a:tailEnd type="none" w="med" len="med"/>
-                    </a:lnL>
-                    <a:lnR w="12700" cap="flat" cmpd="sng" algn="ctr">
-                      <a:solidFill>
-                        <a:srgbClr val="D5DDE8"/>
-                      </a:solidFill>
-                      <a:prstDash val="solid"/>
-                      <a:round/>
-                      <a:headEnd type="none" w="med" len="med"/>
-                      <a:tailEnd type="none" w="med" len="med"/>
-                    </a:lnR>
-                    <a:lnT w="12700" cap="flat" cmpd="sng" algn="ctr">
-                      <a:solidFill>
-                        <a:srgbClr val="D5DDE8"/>
-                      </a:solidFill>
-                      <a:prstDash val="solid"/>
-                      <a:round/>
-                      <a:headEnd type="none" w="med" len="med"/>
-                      <a:tailEnd type="none" w="med" len="med"/>
-                    </a:lnT>
-                    <a:lnB w="12700" cap="flat" cmpd="sng" algn="ctr">
-                      <a:solidFill>
-                        <a:srgbClr val="D5DDE8"/>
-                      </a:solidFill>
-                      <a:prstDash val="solid"/>
-                      <a:round/>
-                      <a:headEnd type="none" w="med" len="med"/>
-                      <a:tailEnd type="none" w="med" len="med"/>
-                    </a:lnB>
-                    <a:solidFill>
-                      <a:srgbClr val="1F2A44"/>
-                    </a:solidFill>
-                  </a:tcPr>
-                </a:tc>
-                <a:extLst>
-                  <a:ext uri="{0D108BD9-81ED-4DB2-BD59-A6C34878D82A}">
-                    <a16:rowId xmlns:a16="http://schemas.microsoft.com/office/drawing/2014/main" val="10000"/>
-                  </a:ext>
-                </a:extLst>
-              </a:tr>
-              <a:tr h="0">
-                <a:tc>
-                  <a:txBody>
-                    <a:bodyPr/>
-                    <a:lstStyle/>
-                    <a:p>
-                      <a:pPr marL="0" indent="0">
-                        <a:buNone/>
-                      </a:pPr>
-                      <a:r>
-                        <a:rPr lang="en-US" sz="1200" b="1" dirty="0">
-                          <a:solidFill>
-                            <a:srgbClr val="1F2A44"/>
-                          </a:solidFill>
-                          <a:latin typeface="Calibri" pitchFamily="34" charset="0"/>
-                          <a:ea typeface="Calibri" pitchFamily="34" charset="-122"/>
-                          <a:cs typeface="Calibri" pitchFamily="34" charset="-120"/>
-                        </a:rPr>
-                        <a:t>Operator calls the chemical spill protocol</a:t>
-                      </a:r>
-                      <a:endParaRPr lang="en-US" sz="1200" dirty="0">
-                        <a:latin typeface="Calibri" charset="0"/>
-                        <a:ea typeface="Calibri" charset="0"/>
-                        <a:cs typeface="Calibri" charset="0"/>
-                      </a:endParaRPr>
-                    </a:p>
-                  </a:txBody>
-                  <a:tcPr marL="73152" marR="73152" marT="73152" marB="73152" anchor="ctr">
-                    <a:lnL w="12700" cap="flat" cmpd="sng" algn="ctr">
-                      <a:solidFill>
-                        <a:srgbClr val="D5DDE8"/>
-                      </a:solidFill>
-                      <a:prstDash val="solid"/>
-                      <a:round/>
-                      <a:headEnd type="none" w="med" len="med"/>
-                      <a:tailEnd type="none" w="med" len="med"/>
-                    </a:lnL>
-                    <a:lnR w="12700" cap="flat" cmpd="sng" algn="ctr">
-                      <a:solidFill>
-                        <a:srgbClr val="D5DDE8"/>
-                      </a:solidFill>
-                      <a:prstDash val="solid"/>
-                      <a:round/>
-                      <a:headEnd type="none" w="med" len="med"/>
-                      <a:tailEnd type="none" w="med" len="med"/>
-                    </a:lnR>
-                    <a:lnT w="12700" cap="flat" cmpd="sng" algn="ctr">
-                      <a:solidFill>
-                        <a:srgbClr val="D5DDE8"/>
-                      </a:solidFill>
-                      <a:prstDash val="solid"/>
-                      <a:round/>
-                      <a:headEnd type="none" w="med" len="med"/>
-                      <a:tailEnd type="none" w="med" len="med"/>
-                    </a:lnT>
-                    <a:lnB w="12700" cap="flat" cmpd="sng" algn="ctr">
-                      <a:solidFill>
-                        <a:srgbClr val="D5DDE8"/>
-                      </a:solidFill>
-                      <a:prstDash val="solid"/>
-                      <a:round/>
-                      <a:headEnd type="none" w="med" len="med"/>
-                      <a:tailEnd type="none" w="med" len="med"/>
-                    </a:lnB>
-                  </a:tcPr>
-                </a:tc>
-                <a:tc>
-                  <a:txBody>
-                    <a:bodyPr/>
-                    <a:lstStyle/>
-                    <a:p>
-                      <a:pPr marL="0" indent="0">
-                        <a:buNone/>
-                      </a:pPr>
-                      <a:r>
-                        <a:rPr lang="en-US" sz="1200" dirty="0">
-                          <a:solidFill>
-                            <a:srgbClr val="1F2A44"/>
-                          </a:solidFill>
-                          <a:latin typeface="Calibri" pitchFamily="34" charset="0"/>
-                          <a:ea typeface="Calibri" pitchFamily="34" charset="-122"/>
-                          <a:cs typeface="Calibri" pitchFamily="34" charset="-120"/>
-                        </a:rPr>
-                        <a:t>CampusEmergencyFacade.cpp, handleChemicalSpillProtocol</a:t>
-                      </a:r>
-                      <a:endParaRPr lang="en-US" sz="1200" dirty="0">
-                        <a:latin typeface="Calibri" charset="0"/>
-                        <a:ea typeface="Calibri" charset="0"/>
-                        <a:cs typeface="Calibri" charset="0"/>
-                      </a:endParaRPr>
-                    </a:p>
-                  </a:txBody>
-                  <a:tcPr marL="73152" marR="73152" marT="73152" marB="73152" anchor="ctr">
-                    <a:lnL w="12700" cap="flat" cmpd="sng" algn="ctr">
-                      <a:solidFill>
-                        <a:srgbClr val="D5DDE8"/>
-                      </a:solidFill>
-                      <a:prstDash val="solid"/>
-                      <a:round/>
-                      <a:headEnd type="none" w="med" len="med"/>
-                      <a:tailEnd type="none" w="med" len="med"/>
-                    </a:lnL>
-                    <a:lnR w="12700" cap="flat" cmpd="sng" algn="ctr">
-                      <a:solidFill>
-                        <a:srgbClr val="D5DDE8"/>
-                      </a:solidFill>
-                      <a:prstDash val="solid"/>
-                      <a:round/>
-                      <a:headEnd type="none" w="med" len="med"/>
-                      <a:tailEnd type="none" w="med" len="med"/>
-                    </a:lnR>
-                    <a:lnT w="12700" cap="flat" cmpd="sng" algn="ctr">
-                      <a:solidFill>
-                        <a:srgbClr val="D5DDE8"/>
-                      </a:solidFill>
-                      <a:prstDash val="solid"/>
-                      <a:round/>
-                      <a:headEnd type="none" w="med" len="med"/>
-                      <a:tailEnd type="none" w="med" len="med"/>
-                    </a:lnT>
-                    <a:lnB w="12700" cap="flat" cmpd="sng" algn="ctr">
-                      <a:solidFill>
-                        <a:srgbClr val="D5DDE8"/>
-                      </a:solidFill>
-                      <a:prstDash val="solid"/>
-                      <a:round/>
-                      <a:headEnd type="none" w="med" len="med"/>
-                      <a:tailEnd type="none" w="med" len="med"/>
-                    </a:lnB>
-                  </a:tcPr>
-                </a:tc>
-                <a:extLst>
-                  <a:ext uri="{0D108BD9-81ED-4DB2-BD59-A6C34878D82A}">
-                    <a16:rowId xmlns:a16="http://schemas.microsoft.com/office/drawing/2014/main" val="10001"/>
-                  </a:ext>
-                </a:extLst>
-              </a:tr>
-              <a:tr h="0">
-                <a:tc>
-                  <a:txBody>
-                    <a:bodyPr/>
-                    <a:lstStyle/>
-                    <a:p>
-                      <a:pPr marL="0" indent="0">
-                        <a:buNone/>
-                      </a:pPr>
-                      <a:r>
-                        <a:rPr lang="en-US" sz="1200" b="1" dirty="0">
-                          <a:solidFill>
-                            <a:srgbClr val="1F2A44"/>
-                          </a:solidFill>
-                          <a:latin typeface="Calibri" pitchFamily="34" charset="0"/>
-                          <a:ea typeface="Calibri" pitchFamily="34" charset="-122"/>
-                          <a:cs typeface="Calibri" pitchFamily="34" charset="-120"/>
-                        </a:rPr>
-                        <a:t>Console is asked to run the command</a:t>
-                      </a:r>
-                      <a:endParaRPr lang="en-US" sz="1200" dirty="0">
-                        <a:latin typeface="Calibri" charset="0"/>
-                        <a:ea typeface="Calibri" charset="0"/>
-                        <a:cs typeface="Calibri" charset="0"/>
-                      </a:endParaRPr>
-                    </a:p>
-                  </a:txBody>
-                  <a:tcPr marL="73152" marR="73152" marT="73152" marB="73152" anchor="ctr">
-                    <a:lnL w="12700" cap="flat" cmpd="sng" algn="ctr">
-                      <a:solidFill>
-                        <a:srgbClr val="D5DDE8"/>
-                      </a:solidFill>
-                      <a:prstDash val="solid"/>
-                      <a:round/>
-                      <a:headEnd type="none" w="med" len="med"/>
-                      <a:tailEnd type="none" w="med" len="med"/>
-                    </a:lnL>
-                    <a:lnR w="12700" cap="flat" cmpd="sng" algn="ctr">
-                      <a:solidFill>
-                        <a:srgbClr val="D5DDE8"/>
-                      </a:solidFill>
-                      <a:prstDash val="solid"/>
-                      <a:round/>
-                      <a:headEnd type="none" w="med" len="med"/>
-                      <a:tailEnd type="none" w="med" len="med"/>
-                    </a:lnR>
-                    <a:lnT w="12700" cap="flat" cmpd="sng" algn="ctr">
-                      <a:solidFill>
-                        <a:srgbClr val="D5DDE8"/>
-                      </a:solidFill>
-                      <a:prstDash val="solid"/>
-                      <a:round/>
-                      <a:headEnd type="none" w="med" len="med"/>
-                      <a:tailEnd type="none" w="med" len="med"/>
-                    </a:lnT>
-                    <a:lnB w="12700" cap="flat" cmpd="sng" algn="ctr">
-                      <a:solidFill>
-                        <a:srgbClr val="D5DDE8"/>
-                      </a:solidFill>
-                      <a:prstDash val="solid"/>
-                      <a:round/>
-                      <a:headEnd type="none" w="med" len="med"/>
-                      <a:tailEnd type="none" w="med" len="med"/>
-                    </a:lnB>
-                  </a:tcPr>
-                </a:tc>
-                <a:tc>
-                  <a:txBody>
-                    <a:bodyPr/>
-                    <a:lstStyle/>
-                    <a:p>
-                      <a:pPr marL="0" indent="0">
-                        <a:buNone/>
-                      </a:pPr>
-                      <a:r>
-                        <a:rPr lang="en-US" sz="1200" dirty="0">
-                          <a:solidFill>
-                            <a:srgbClr val="1F2A44"/>
-                          </a:solidFill>
-                          <a:latin typeface="Calibri" pitchFamily="34" charset="0"/>
-                          <a:ea typeface="Calibri" pitchFamily="34" charset="-122"/>
-                          <a:cs typeface="Calibri" pitchFamily="34" charset="-120"/>
-                        </a:rPr>
-                        <a:t>OperatorConsole::executeCommand</a:t>
-                      </a:r>
-                      <a:endParaRPr lang="en-US" sz="1200" dirty="0">
-                        <a:latin typeface="Calibri" charset="0"/>
-                        <a:ea typeface="Calibri" charset="0"/>
-                        <a:cs typeface="Calibri" charset="0"/>
-                      </a:endParaRPr>
-                    </a:p>
-                  </a:txBody>
-                  <a:tcPr marL="73152" marR="73152" marT="73152" marB="73152" anchor="ctr">
-                    <a:lnL w="12700" cap="flat" cmpd="sng" algn="ctr">
-                      <a:solidFill>
-                        <a:srgbClr val="D5DDE8"/>
-                      </a:solidFill>
-                      <a:prstDash val="solid"/>
-                      <a:round/>
-                      <a:headEnd type="none" w="med" len="med"/>
-                      <a:tailEnd type="none" w="med" len="med"/>
-                    </a:lnL>
-                    <a:lnR w="12700" cap="flat" cmpd="sng" algn="ctr">
-                      <a:solidFill>
-                        <a:srgbClr val="D5DDE8"/>
-                      </a:solidFill>
-                      <a:prstDash val="solid"/>
-                      <a:round/>
-                      <a:headEnd type="none" w="med" len="med"/>
-                      <a:tailEnd type="none" w="med" len="med"/>
-                    </a:lnR>
-                    <a:lnT w="12700" cap="flat" cmpd="sng" algn="ctr">
-                      <a:solidFill>
-                        <a:srgbClr val="D5DDE8"/>
-                      </a:solidFill>
-                      <a:prstDash val="solid"/>
-                      <a:round/>
-                      <a:headEnd type="none" w="med" len="med"/>
-                      <a:tailEnd type="none" w="med" len="med"/>
-                    </a:lnT>
-                    <a:lnB w="12700" cap="flat" cmpd="sng" algn="ctr">
-                      <a:solidFill>
-                        <a:srgbClr val="D5DDE8"/>
-                      </a:solidFill>
-                      <a:prstDash val="solid"/>
-                      <a:round/>
-                      <a:headEnd type="none" w="med" len="med"/>
-                      <a:tailEnd type="none" w="med" len="med"/>
-                    </a:lnB>
-                  </a:tcPr>
-                </a:tc>
-                <a:extLst>
-                  <a:ext uri="{0D108BD9-81ED-4DB2-BD59-A6C34878D82A}">
-                    <a16:rowId xmlns:a16="http://schemas.microsoft.com/office/drawing/2014/main" val="10002"/>
-                  </a:ext>
-                </a:extLst>
-              </a:tr>
-              <a:tr h="0">
-                <a:tc>
-                  <a:txBody>
-                    <a:bodyPr/>
-                    <a:lstStyle/>
-                    <a:p>
-                      <a:pPr marL="0" indent="0">
-                        <a:buNone/>
-                      </a:pPr>
-                      <a:r>
-                        <a:rPr lang="en-US" sz="1200" b="1" dirty="0">
-                          <a:solidFill>
-                            <a:srgbClr val="1F2A44"/>
-                          </a:solidFill>
-                          <a:latin typeface="Calibri" pitchFamily="34" charset="0"/>
-                          <a:ea typeface="Calibri" pitchFamily="34" charset="-122"/>
-                          <a:cs typeface="Calibri" pitchFamily="34" charset="-120"/>
-                        </a:rPr>
-                        <a:t>Command is executed</a:t>
-                      </a:r>
-                      <a:endParaRPr lang="en-US" sz="1200" dirty="0">
-                        <a:latin typeface="Calibri" charset="0"/>
-                        <a:ea typeface="Calibri" charset="0"/>
-                        <a:cs typeface="Calibri" charset="0"/>
-                      </a:endParaRPr>
-                    </a:p>
-                  </a:txBody>
-                  <a:tcPr marL="73152" marR="73152" marT="73152" marB="73152" anchor="ctr">
-                    <a:lnL w="12700" cap="flat" cmpd="sng" algn="ctr">
-                      <a:solidFill>
-                        <a:srgbClr val="D5DDE8"/>
-                      </a:solidFill>
-                      <a:prstDash val="solid"/>
-                      <a:round/>
-                      <a:headEnd type="none" w="med" len="med"/>
-                      <a:tailEnd type="none" w="med" len="med"/>
-                    </a:lnL>
-                    <a:lnR w="12700" cap="flat" cmpd="sng" algn="ctr">
-                      <a:solidFill>
-                        <a:srgbClr val="D5DDE8"/>
-                      </a:solidFill>
-                      <a:prstDash val="solid"/>
-                      <a:round/>
-                      <a:headEnd type="none" w="med" len="med"/>
-                      <a:tailEnd type="none" w="med" len="med"/>
-                    </a:lnR>
-                    <a:lnT w="12700" cap="flat" cmpd="sng" algn="ctr">
-                      <a:solidFill>
-                        <a:srgbClr val="D5DDE8"/>
-                      </a:solidFill>
-                      <a:prstDash val="solid"/>
-                      <a:round/>
-                      <a:headEnd type="none" w="med" len="med"/>
-                      <a:tailEnd type="none" w="med" len="med"/>
-                    </a:lnT>
-                    <a:lnB w="12700" cap="flat" cmpd="sng" algn="ctr">
-                      <a:solidFill>
-                        <a:srgbClr val="D5DDE8"/>
-                      </a:solidFill>
-                      <a:prstDash val="solid"/>
-                      <a:round/>
-                      <a:headEnd type="none" w="med" len="med"/>
-                      <a:tailEnd type="none" w="med" len="med"/>
-                    </a:lnB>
-                  </a:tcPr>
-                </a:tc>
-                <a:tc>
-                  <a:txBody>
-                    <a:bodyPr/>
-                    <a:lstStyle/>
-                    <a:p>
-                      <a:pPr marL="0" indent="0">
-                        <a:buNone/>
-                      </a:pPr>
-                      <a:r>
-                        <a:rPr lang="en-US" sz="1200" dirty="0">
-                          <a:solidFill>
-                            <a:srgbClr val="1F2A44"/>
-                          </a:solidFill>
-                          <a:latin typeface="Calibri" pitchFamily="34" charset="0"/>
-                          <a:ea typeface="Calibri" pitchFamily="34" charset="-122"/>
-                          <a:cs typeface="Calibri" pitchFamily="34" charset="-120"/>
-                        </a:rPr>
-                        <a:t>ApplyStrategyCommand::execute</a:t>
-                      </a:r>
-                      <a:endParaRPr lang="en-US" sz="1200" dirty="0">
-                        <a:latin typeface="Calibri" charset="0"/>
-                        <a:ea typeface="Calibri" charset="0"/>
-                        <a:cs typeface="Calibri" charset="0"/>
-                      </a:endParaRPr>
-                    </a:p>
-                  </a:txBody>
-                  <a:tcPr marL="73152" marR="73152" marT="73152" marB="73152" anchor="ctr">
-                    <a:lnL w="12700" cap="flat" cmpd="sng" algn="ctr">
-                      <a:solidFill>
-                        <a:srgbClr val="D5DDE8"/>
-                      </a:solidFill>
-                      <a:prstDash val="solid"/>
-                      <a:round/>
-                      <a:headEnd type="none" w="med" len="med"/>
-                      <a:tailEnd type="none" w="med" len="med"/>
-                    </a:lnL>
-                    <a:lnR w="12700" cap="flat" cmpd="sng" algn="ctr">
-                      <a:solidFill>
-                        <a:srgbClr val="D5DDE8"/>
-                      </a:solidFill>
-                      <a:prstDash val="solid"/>
-                      <a:round/>
-                      <a:headEnd type="none" w="med" len="med"/>
-                      <a:tailEnd type="none" w="med" len="med"/>
-                    </a:lnR>
-                    <a:lnT w="12700" cap="flat" cmpd="sng" algn="ctr">
-                      <a:solidFill>
-                        <a:srgbClr val="D5DDE8"/>
-                      </a:solidFill>
-                      <a:prstDash val="solid"/>
-                      <a:round/>
-                      <a:headEnd type="none" w="med" len="med"/>
-                      <a:tailEnd type="none" w="med" len="med"/>
-                    </a:lnT>
-                    <a:lnB w="12700" cap="flat" cmpd="sng" algn="ctr">
-                      <a:solidFill>
-                        <a:srgbClr val="D5DDE8"/>
-                      </a:solidFill>
-                      <a:prstDash val="solid"/>
-                      <a:round/>
-                      <a:headEnd type="none" w="med" len="med"/>
-                      <a:tailEnd type="none" w="med" len="med"/>
-                    </a:lnB>
-                  </a:tcPr>
-                </a:tc>
-                <a:extLst>
-                  <a:ext uri="{0D108BD9-81ED-4DB2-BD59-A6C34878D82A}">
-                    <a16:rowId xmlns:a16="http://schemas.microsoft.com/office/drawing/2014/main" val="10003"/>
-                  </a:ext>
-                </a:extLst>
-              </a:tr>
-              <a:tr h="0">
-                <a:tc>
-                  <a:txBody>
-                    <a:bodyPr/>
-                    <a:lstStyle/>
-                    <a:p>
-                      <a:pPr marL="0" indent="0">
-                        <a:buNone/>
-                      </a:pPr>
-                      <a:r>
-                        <a:rPr lang="en-US" sz="1200" b="1" dirty="0">
-                          <a:solidFill>
-                            <a:srgbClr val="1F2A44"/>
-                          </a:solidFill>
-                          <a:latin typeface="Calibri" pitchFamily="34" charset="0"/>
-                          <a:ea typeface="Calibri" pitchFamily="34" charset="-122"/>
-                          <a:cs typeface="Calibri" pitchFamily="34" charset="-120"/>
-                        </a:rPr>
-                        <a:t>Incident is told to dispatch responders</a:t>
-                      </a:r>
-                      <a:endParaRPr lang="en-US" sz="1200" dirty="0">
-                        <a:latin typeface="Calibri" charset="0"/>
-                        <a:ea typeface="Calibri" charset="0"/>
-                        <a:cs typeface="Calibri" charset="0"/>
-                      </a:endParaRPr>
-                    </a:p>
-                  </a:txBody>
-                  <a:tcPr marL="73152" marR="73152" marT="73152" marB="73152" anchor="ctr">
-                    <a:lnL w="12700" cap="flat" cmpd="sng" algn="ctr">
-                      <a:solidFill>
-                        <a:srgbClr val="D5DDE8"/>
-                      </a:solidFill>
-                      <a:prstDash val="solid"/>
-                      <a:round/>
-                      <a:headEnd type="none" w="med" len="med"/>
-                      <a:tailEnd type="none" w="med" len="med"/>
-                    </a:lnL>
-                    <a:lnR w="12700" cap="flat" cmpd="sng" algn="ctr">
-                      <a:solidFill>
-                        <a:srgbClr val="D5DDE8"/>
-                      </a:solidFill>
-                      <a:prstDash val="solid"/>
-                      <a:round/>
-                      <a:headEnd type="none" w="med" len="med"/>
-                      <a:tailEnd type="none" w="med" len="med"/>
-                    </a:lnR>
-                    <a:lnT w="12700" cap="flat" cmpd="sng" algn="ctr">
-                      <a:solidFill>
-                        <a:srgbClr val="D5DDE8"/>
-                      </a:solidFill>
-                      <a:prstDash val="solid"/>
-                      <a:round/>
-                      <a:headEnd type="none" w="med" len="med"/>
-                      <a:tailEnd type="none" w="med" len="med"/>
-                    </a:lnT>
-                    <a:lnB w="12700" cap="flat" cmpd="sng" algn="ctr">
-                      <a:solidFill>
-                        <a:srgbClr val="D5DDE8"/>
-                      </a:solidFill>
-                      <a:prstDash val="solid"/>
-                      <a:round/>
-                      <a:headEnd type="none" w="med" len="med"/>
-                      <a:tailEnd type="none" w="med" len="med"/>
-                    </a:lnB>
-                  </a:tcPr>
-                </a:tc>
-                <a:tc>
-                  <a:txBody>
-                    <a:bodyPr/>
-                    <a:lstStyle/>
-                    <a:p>
-                      <a:pPr marL="0" indent="0">
-                        <a:buNone/>
-                      </a:pPr>
-                      <a:r>
-                        <a:rPr lang="en-US" sz="1200" dirty="0">
-                          <a:solidFill>
-                            <a:srgbClr val="1F2A44"/>
-                          </a:solidFill>
-                          <a:latin typeface="Calibri" pitchFamily="34" charset="0"/>
-                          <a:ea typeface="Calibri" pitchFamily="34" charset="-122"/>
-                          <a:cs typeface="Calibri" pitchFamily="34" charset="-120"/>
-                        </a:rPr>
-                        <a:t>Incident::dispatchResponders</a:t>
-                      </a:r>
-                      <a:endParaRPr lang="en-US" sz="1200" dirty="0">
-                        <a:latin typeface="Calibri" charset="0"/>
-                        <a:ea typeface="Calibri" charset="0"/>
-                        <a:cs typeface="Calibri" charset="0"/>
-                      </a:endParaRPr>
-                    </a:p>
-                  </a:txBody>
-                  <a:tcPr marL="73152" marR="73152" marT="73152" marB="73152" anchor="ctr">
-                    <a:lnL w="12700" cap="flat" cmpd="sng" algn="ctr">
-                      <a:solidFill>
-                        <a:srgbClr val="D5DDE8"/>
-                      </a:solidFill>
-                      <a:prstDash val="solid"/>
-                      <a:round/>
-                      <a:headEnd type="none" w="med" len="med"/>
-                      <a:tailEnd type="none" w="med" len="med"/>
-                    </a:lnL>
-                    <a:lnR w="12700" cap="flat" cmpd="sng" algn="ctr">
-                      <a:solidFill>
-                        <a:srgbClr val="D5DDE8"/>
-                      </a:solidFill>
-                      <a:prstDash val="solid"/>
-                      <a:round/>
-                      <a:headEnd type="none" w="med" len="med"/>
-                      <a:tailEnd type="none" w="med" len="med"/>
-                    </a:lnR>
-                    <a:lnT w="12700" cap="flat" cmpd="sng" algn="ctr">
-                      <a:solidFill>
-                        <a:srgbClr val="D5DDE8"/>
-                      </a:solidFill>
-                      <a:prstDash val="solid"/>
-                      <a:round/>
-                      <a:headEnd type="none" w="med" len="med"/>
-                      <a:tailEnd type="none" w="med" len="med"/>
-                    </a:lnT>
-                    <a:lnB w="12700" cap="flat" cmpd="sng" algn="ctr">
-                      <a:solidFill>
-                        <a:srgbClr val="D5DDE8"/>
-                      </a:solidFill>
-                      <a:prstDash val="solid"/>
-                      <a:round/>
-                      <a:headEnd type="none" w="med" len="med"/>
-                      <a:tailEnd type="none" w="med" len="med"/>
-                    </a:lnB>
-                  </a:tcPr>
-                </a:tc>
-                <a:extLst>
-                  <a:ext uri="{0D108BD9-81ED-4DB2-BD59-A6C34878D82A}">
-                    <a16:rowId xmlns:a16="http://schemas.microsoft.com/office/drawing/2014/main" val="10004"/>
-                  </a:ext>
-                </a:extLst>
-              </a:tr>
-              <a:tr h="0">
-                <a:tc>
-                  <a:txBody>
-                    <a:bodyPr/>
-                    <a:lstStyle/>
-                    <a:p>
-                      <a:pPr marL="0" indent="0">
-                        <a:buNone/>
-                      </a:pPr>
-                      <a:r>
-                        <a:rPr lang="en-US" sz="1200" b="1" dirty="0">
-                          <a:solidFill>
-                            <a:srgbClr val="1F2A44"/>
-                          </a:solidFill>
-                          <a:latin typeface="Calibri" pitchFamily="34" charset="0"/>
-                          <a:ea typeface="Calibri" pitchFamily="34" charset="-122"/>
-                          <a:cs typeface="Calibri" pitchFamily="34" charset="-120"/>
-                        </a:rPr>
-                        <a:t>The chosen tactic actually runs</a:t>
-                      </a:r>
-                      <a:endParaRPr lang="en-US" sz="1200" dirty="0">
-                        <a:latin typeface="Calibri" charset="0"/>
-                        <a:ea typeface="Calibri" charset="0"/>
-                        <a:cs typeface="Calibri" charset="0"/>
-                      </a:endParaRPr>
-                    </a:p>
-                  </a:txBody>
-                  <a:tcPr marL="73152" marR="73152" marT="73152" marB="73152" anchor="ctr">
-                    <a:lnL w="12700" cap="flat" cmpd="sng" algn="ctr">
-                      <a:solidFill>
-                        <a:srgbClr val="D5DDE8"/>
-                      </a:solidFill>
-                      <a:prstDash val="solid"/>
-                      <a:round/>
-                      <a:headEnd type="none" w="med" len="med"/>
-                      <a:tailEnd type="none" w="med" len="med"/>
-                    </a:lnL>
-                    <a:lnR w="12700" cap="flat" cmpd="sng" algn="ctr">
-                      <a:solidFill>
-                        <a:srgbClr val="D5DDE8"/>
-                      </a:solidFill>
-                      <a:prstDash val="solid"/>
-                      <a:round/>
-                      <a:headEnd type="none" w="med" len="med"/>
-                      <a:tailEnd type="none" w="med" len="med"/>
-                    </a:lnR>
-                    <a:lnT w="12700" cap="flat" cmpd="sng" algn="ctr">
-                      <a:solidFill>
-                        <a:srgbClr val="D5DDE8"/>
-                      </a:solidFill>
-                      <a:prstDash val="solid"/>
-                      <a:round/>
-                      <a:headEnd type="none" w="med" len="med"/>
-                      <a:tailEnd type="none" w="med" len="med"/>
-                    </a:lnT>
-                    <a:lnB w="12700" cap="flat" cmpd="sng" algn="ctr">
-                      <a:solidFill>
-                        <a:srgbClr val="D5DDE8"/>
-                      </a:solidFill>
-                      <a:prstDash val="solid"/>
-                      <a:round/>
-                      <a:headEnd type="none" w="med" len="med"/>
-                      <a:tailEnd type="none" w="med" len="med"/>
-                    </a:lnB>
-                  </a:tcPr>
-                </a:tc>
-                <a:tc>
-                  <a:txBody>
-                    <a:bodyPr/>
-                    <a:lstStyle/>
-                    <a:p>
-                      <a:pPr marL="0" indent="0">
-                        <a:buNone/>
-                      </a:pPr>
-                      <a:r>
-                        <a:rPr lang="en-US" sz="1200" dirty="0">
-                          <a:solidFill>
-                            <a:srgbClr val="1F2A44"/>
-                          </a:solidFill>
-                          <a:latin typeface="Calibri" pitchFamily="34" charset="0"/>
-                          <a:ea typeface="Calibri" pitchFamily="34" charset="-122"/>
-                          <a:cs typeface="Calibri" pitchFamily="34" charset="-120"/>
-                        </a:rPr>
-                        <a:t>LockdownContainmentStrategy::executeTactic</a:t>
-                      </a:r>
-                      <a:endParaRPr lang="en-US" sz="1200" dirty="0">
-                        <a:latin typeface="Calibri" charset="0"/>
-                        <a:ea typeface="Calibri" charset="0"/>
-                        <a:cs typeface="Calibri" charset="0"/>
-                      </a:endParaRPr>
-                    </a:p>
-                  </a:txBody>
-                  <a:tcPr marL="73152" marR="73152" marT="73152" marB="73152" anchor="ctr">
-                    <a:lnL w="12700" cap="flat" cmpd="sng" algn="ctr">
-                      <a:solidFill>
-                        <a:srgbClr val="D5DDE8"/>
-                      </a:solidFill>
-                      <a:prstDash val="solid"/>
-                      <a:round/>
-                      <a:headEnd type="none" w="med" len="med"/>
-                      <a:tailEnd type="none" w="med" len="med"/>
-                    </a:lnL>
-                    <a:lnR w="12700" cap="flat" cmpd="sng" algn="ctr">
-                      <a:solidFill>
-                        <a:srgbClr val="D5DDE8"/>
-                      </a:solidFill>
-                      <a:prstDash val="solid"/>
-                      <a:round/>
-                      <a:headEnd type="none" w="med" len="med"/>
-                      <a:tailEnd type="none" w="med" len="med"/>
-                    </a:lnR>
-                    <a:lnT w="12700" cap="flat" cmpd="sng" algn="ctr">
-                      <a:solidFill>
-                        <a:srgbClr val="D5DDE8"/>
-                      </a:solidFill>
-                      <a:prstDash val="solid"/>
-                      <a:round/>
-                      <a:headEnd type="none" w="med" len="med"/>
-                      <a:tailEnd type="none" w="med" len="med"/>
-                    </a:lnT>
-                    <a:lnB w="12700" cap="flat" cmpd="sng" algn="ctr">
-                      <a:solidFill>
-                        <a:srgbClr val="D5DDE8"/>
-                      </a:solidFill>
-                      <a:prstDash val="solid"/>
-                      <a:round/>
-                      <a:headEnd type="none" w="med" len="med"/>
-                      <a:tailEnd type="none" w="med" len="med"/>
-                    </a:lnB>
-                  </a:tcPr>
-                </a:tc>
-                <a:extLst>
-                  <a:ext uri="{0D108BD9-81ED-4DB2-BD59-A6C34878D82A}">
-                    <a16:rowId xmlns:a16="http://schemas.microsoft.com/office/drawing/2014/main" val="10005"/>
-                  </a:ext>
-                </a:extLst>
-              </a:tr>
-              <a:tr h="0">
-                <a:tc>
-                  <a:txBody>
-                    <a:bodyPr/>
-                    <a:lstStyle/>
-                    <a:p>
-                      <a:pPr marL="0" indent="0">
-                        <a:buNone/>
-                      </a:pPr>
-                      <a:r>
-                        <a:rPr lang="en-US" sz="1200" b="1" dirty="0">
-                          <a:solidFill>
-                            <a:srgbClr val="1F2A44"/>
-                          </a:solidFill>
-                          <a:latin typeface="Calibri" pitchFamily="34" charset="0"/>
-                          <a:ea typeface="Calibri" pitchFamily="34" charset="-122"/>
-                          <a:cs typeface="Calibri" pitchFamily="34" charset="-120"/>
-                        </a:rPr>
-                        <a:t>The zone gets locked through the adapter</a:t>
-                      </a:r>
-                      <a:endParaRPr lang="en-US" sz="1200" dirty="0">
-                        <a:latin typeface="Calibri" charset="0"/>
-                        <a:ea typeface="Calibri" charset="0"/>
-                        <a:cs typeface="Calibri" charset="0"/>
-                      </a:endParaRPr>
-                    </a:p>
-                  </a:txBody>
-                  <a:tcPr marL="73152" marR="73152" marT="73152" marB="73152" anchor="ctr">
-                    <a:lnL w="12700" cap="flat" cmpd="sng" algn="ctr">
-                      <a:solidFill>
-                        <a:srgbClr val="D5DDE8"/>
-                      </a:solidFill>
-                      <a:prstDash val="solid"/>
-                      <a:round/>
-                      <a:headEnd type="none" w="med" len="med"/>
-                      <a:tailEnd type="none" w="med" len="med"/>
-                    </a:lnL>
-                    <a:lnR w="12700" cap="flat" cmpd="sng" algn="ctr">
-                      <a:solidFill>
-                        <a:srgbClr val="D5DDE8"/>
-                      </a:solidFill>
-                      <a:prstDash val="solid"/>
-                      <a:round/>
-                      <a:headEnd type="none" w="med" len="med"/>
-                      <a:tailEnd type="none" w="med" len="med"/>
-                    </a:lnR>
-                    <a:lnT w="12700" cap="flat" cmpd="sng" algn="ctr">
-                      <a:solidFill>
-                        <a:srgbClr val="D5DDE8"/>
-                      </a:solidFill>
-                      <a:prstDash val="solid"/>
-                      <a:round/>
-                      <a:headEnd type="none" w="med" len="med"/>
-                      <a:tailEnd type="none" w="med" len="med"/>
-                    </a:lnT>
-                    <a:lnB w="12700" cap="flat" cmpd="sng" algn="ctr">
-                      <a:solidFill>
-                        <a:srgbClr val="D5DDE8"/>
-                      </a:solidFill>
-                      <a:prstDash val="solid"/>
-                      <a:round/>
-                      <a:headEnd type="none" w="med" len="med"/>
-                      <a:tailEnd type="none" w="med" len="med"/>
-                    </a:lnB>
-                  </a:tcPr>
-                </a:tc>
-                <a:tc>
-                  <a:txBody>
-                    <a:bodyPr/>
-                    <a:lstStyle/>
-                    <a:p>
-                      <a:pPr marL="0" indent="0">
-                        <a:buNone/>
-                      </a:pPr>
-                      <a:r>
-                        <a:rPr lang="en-US" sz="1200" dirty="0">
-                          <a:solidFill>
-                            <a:srgbClr val="1F2A44"/>
-                          </a:solidFill>
-                          <a:latin typeface="Calibri" pitchFamily="34" charset="0"/>
-                          <a:ea typeface="Calibri" pitchFamily="34" charset="-122"/>
-                          <a:cs typeface="Calibri" pitchFamily="34" charset="-120"/>
-                        </a:rPr>
-                        <a:t>TurnstileAdapter::lockZone</a:t>
-                      </a:r>
-                      <a:endParaRPr lang="en-US" sz="1200" dirty="0">
-                        <a:latin typeface="Calibri" charset="0"/>
-                        <a:ea typeface="Calibri" charset="0"/>
-                        <a:cs typeface="Calibri" charset="0"/>
-                      </a:endParaRPr>
-                    </a:p>
-                  </a:txBody>
-                  <a:tcPr marL="73152" marR="73152" marT="73152" marB="73152" anchor="ctr">
-                    <a:lnL w="12700" cap="flat" cmpd="sng" algn="ctr">
-                      <a:solidFill>
-                        <a:srgbClr val="D5DDE8"/>
-                      </a:solidFill>
-                      <a:prstDash val="solid"/>
-                      <a:round/>
-                      <a:headEnd type="none" w="med" len="med"/>
-                      <a:tailEnd type="none" w="med" len="med"/>
-                    </a:lnL>
-                    <a:lnR w="12700" cap="flat" cmpd="sng" algn="ctr">
-                      <a:solidFill>
-                        <a:srgbClr val="D5DDE8"/>
-                      </a:solidFill>
-                      <a:prstDash val="solid"/>
-                      <a:round/>
-                      <a:headEnd type="none" w="med" len="med"/>
-                      <a:tailEnd type="none" w="med" len="med"/>
-                    </a:lnR>
-                    <a:lnT w="12700" cap="flat" cmpd="sng" algn="ctr">
-                      <a:solidFill>
-                        <a:srgbClr val="D5DDE8"/>
-                      </a:solidFill>
-                      <a:prstDash val="solid"/>
-                      <a:round/>
-                      <a:headEnd type="none" w="med" len="med"/>
-                      <a:tailEnd type="none" w="med" len="med"/>
-                    </a:lnT>
-                    <a:lnB w="12700" cap="flat" cmpd="sng" algn="ctr">
-                      <a:solidFill>
-                        <a:srgbClr val="D5DDE8"/>
-                      </a:solidFill>
-                      <a:prstDash val="solid"/>
-                      <a:round/>
-                      <a:headEnd type="none" w="med" len="med"/>
-                      <a:tailEnd type="none" w="med" len="med"/>
-                    </a:lnB>
-                  </a:tcPr>
-                </a:tc>
-                <a:extLst>
-                  <a:ext uri="{0D108BD9-81ED-4DB2-BD59-A6C34878D82A}">
-                    <a16:rowId xmlns:a16="http://schemas.microsoft.com/office/drawing/2014/main" val="10006"/>
-                  </a:ext>
-                </a:extLst>
-              </a:tr>
-              <a:tr h="0">
-                <a:tc>
-                  <a:txBody>
-                    <a:bodyPr/>
-                    <a:lstStyle/>
-                    <a:p>
-                      <a:pPr marL="0" indent="0">
-                        <a:buNone/>
-                      </a:pPr>
-                      <a:r>
-                        <a:rPr lang="en-US" sz="1200" b="1" dirty="0">
-                          <a:solidFill>
-                            <a:srgbClr val="1F2A44"/>
-                          </a:solidFill>
-                          <a:latin typeface="Calibri" pitchFamily="34" charset="0"/>
-                          <a:ea typeface="Calibri" pitchFamily="34" charset="-122"/>
-                          <a:cs typeface="Calibri" pitchFamily="34" charset="-120"/>
-                        </a:rPr>
-                        <a:t>Every team is notified</a:t>
-                      </a:r>
-                      <a:endParaRPr lang="en-US" sz="1200" dirty="0">
-                        <a:latin typeface="Calibri" charset="0"/>
-                        <a:ea typeface="Calibri" charset="0"/>
-                        <a:cs typeface="Calibri" charset="0"/>
-                      </a:endParaRPr>
-                    </a:p>
-                  </a:txBody>
-                  <a:tcPr marL="73152" marR="73152" marT="73152" marB="73152" anchor="ctr">
-                    <a:lnL w="12700" cap="flat" cmpd="sng" algn="ctr">
-                      <a:solidFill>
-                        <a:srgbClr val="D5DDE8"/>
-                      </a:solidFill>
-                      <a:prstDash val="solid"/>
-                      <a:round/>
-                      <a:headEnd type="none" w="med" len="med"/>
-                      <a:tailEnd type="none" w="med" len="med"/>
-                    </a:lnL>
-                    <a:lnR w="12700" cap="flat" cmpd="sng" algn="ctr">
-                      <a:solidFill>
-                        <a:srgbClr val="D5DDE8"/>
-                      </a:solidFill>
-                      <a:prstDash val="solid"/>
-                      <a:round/>
-                      <a:headEnd type="none" w="med" len="med"/>
-                      <a:tailEnd type="none" w="med" len="med"/>
-                    </a:lnR>
-                    <a:lnT w="12700" cap="flat" cmpd="sng" algn="ctr">
-                      <a:solidFill>
-                        <a:srgbClr val="D5DDE8"/>
-                      </a:solidFill>
-                      <a:prstDash val="solid"/>
-                      <a:round/>
-                      <a:headEnd type="none" w="med" len="med"/>
-                      <a:tailEnd type="none" w="med" len="med"/>
-                    </a:lnT>
-                    <a:lnB w="12700" cap="flat" cmpd="sng" algn="ctr">
-                      <a:solidFill>
-                        <a:srgbClr val="D5DDE8"/>
-                      </a:solidFill>
-                      <a:prstDash val="solid"/>
-                      <a:round/>
-                      <a:headEnd type="none" w="med" len="med"/>
-                      <a:tailEnd type="none" w="med" len="med"/>
-                    </a:lnB>
-                  </a:tcPr>
-                </a:tc>
-                <a:tc>
-                  <a:txBody>
-                    <a:bodyPr/>
-                    <a:lstStyle/>
-                    <a:p>
-                      <a:pPr marL="0" indent="0">
-                        <a:buNone/>
-                      </a:pPr>
-                      <a:r>
-                        <a:rPr lang="en-US" sz="1200" dirty="0">
-                          <a:solidFill>
-                            <a:srgbClr val="1F2A44"/>
-                          </a:solidFill>
-                          <a:latin typeface="Calibri" pitchFamily="34" charset="0"/>
-                          <a:ea typeface="Calibri" pitchFamily="34" charset="-122"/>
-                          <a:cs typeface="Calibri" pitchFamily="34" charset="-120"/>
-                        </a:rPr>
-                        <a:t>CentralDispatchMediator::notify</a:t>
-                      </a:r>
-                      <a:endParaRPr lang="en-US" sz="1200" dirty="0">
-                        <a:latin typeface="Calibri" charset="0"/>
-                        <a:ea typeface="Calibri" charset="0"/>
-                        <a:cs typeface="Calibri" charset="0"/>
-                      </a:endParaRPr>
-                    </a:p>
-                  </a:txBody>
-                  <a:tcPr marL="73152" marR="73152" marT="73152" marB="73152" anchor="ctr">
-                    <a:lnL w="12700" cap="flat" cmpd="sng" algn="ctr">
-                      <a:solidFill>
-                        <a:srgbClr val="D5DDE8"/>
-                      </a:solidFill>
-                      <a:prstDash val="solid"/>
-                      <a:round/>
-                      <a:headEnd type="none" w="med" len="med"/>
-                      <a:tailEnd type="none" w="med" len="med"/>
-                    </a:lnL>
-                    <a:lnR w="12700" cap="flat" cmpd="sng" algn="ctr">
-                      <a:solidFill>
-                        <a:srgbClr val="D5DDE8"/>
-                      </a:solidFill>
-                      <a:prstDash val="solid"/>
-                      <a:round/>
-                      <a:headEnd type="none" w="med" len="med"/>
-                      <a:tailEnd type="none" w="med" len="med"/>
-                    </a:lnR>
-                    <a:lnT w="12700" cap="flat" cmpd="sng" algn="ctr">
-                      <a:solidFill>
-                        <a:srgbClr val="D5DDE8"/>
-                      </a:solidFill>
-                      <a:prstDash val="solid"/>
-                      <a:round/>
-                      <a:headEnd type="none" w="med" len="med"/>
-                      <a:tailEnd type="none" w="med" len="med"/>
-                    </a:lnT>
-                    <a:lnB w="12700" cap="flat" cmpd="sng" algn="ctr">
-                      <a:solidFill>
-                        <a:srgbClr val="D5DDE8"/>
-                      </a:solidFill>
-                      <a:prstDash val="solid"/>
-                      <a:round/>
-                      <a:headEnd type="none" w="med" len="med"/>
-                      <a:tailEnd type="none" w="med" len="med"/>
-                    </a:lnB>
-                  </a:tcPr>
-                </a:tc>
-                <a:extLst>
-                  <a:ext uri="{0D108BD9-81ED-4DB2-BD59-A6C34878D82A}">
-                    <a16:rowId xmlns:a16="http://schemas.microsoft.com/office/drawing/2014/main" val="10007"/>
-                  </a:ext>
-                </a:extLst>
-              </a:tr>
-            </a:tbl>
-          </a:graphicData>
-        </a:graphic>
-      </p:graphicFrame>
     </p:spTree>
   </p:cSld>
   <p:clrMapOvr>

</xml_diff>